<commit_message>
Added SGHIRG updated slides
</commit_message>
<xml_diff>
--- a/AI-Research-Day-Presentation-Daniel-Sikar-Dave-Muir.pptx
+++ b/AI-Research-Day-Presentation-Daniel-Sikar-Dave-Muir.pptx
@@ -5,7 +5,7 @@
     <p:sldMasterId id="2147483660" r:id="rId1"/>
   </p:sldMasterIdLst>
   <p:notesMasterIdLst>
-    <p:notesMasterId r:id="rId13"/>
+    <p:notesMasterId r:id="rId14"/>
   </p:notesMasterIdLst>
   <p:sldIdLst>
     <p:sldId id="285" r:id="rId2"/>
@@ -18,13 +18,14 @@
     <p:sldId id="299" r:id="rId9"/>
     <p:sldId id="302" r:id="rId10"/>
     <p:sldId id="303" r:id="rId11"/>
-    <p:sldId id="300" r:id="rId12"/>
+    <p:sldId id="326" r:id="rId12"/>
+    <p:sldId id="300" r:id="rId13"/>
   </p:sldIdLst>
   <p:sldSz cx="12192000" cy="6858000"/>
   <p:notesSz cx="6858000" cy="9144000"/>
   <p:defaultTextStyle>
     <a:defPPr>
-      <a:defRPr lang="en-US"/>
+      <a:defRPr lang="en-GB"/>
     </a:defPPr>
     <a:lvl1pPr marL="0" algn="l" defTabSz="914400" rtl="0" eaLnBrk="1" latinLnBrk="0" hangingPunct="1">
       <a:defRPr sz="1800" kern="1200">
@@ -128,7 +129,7 @@
 <file path=ppt/revisionInfo.xml><?xml version="1.0" encoding="utf-8"?>
 <p1510:revInfo xmlns:a="http://schemas.openxmlformats.org/drawingml/2006/main" xmlns:r="http://schemas.openxmlformats.org/officeDocument/2006/relationships" xmlns:p1510="http://schemas.microsoft.com/office/powerpoint/2015/10/main">
   <p1510:revLst>
-    <p1510:client id="{1C03B98C-27EA-6290-5363-CC0D4CEC0E53}" v="115" dt="2026-06-18T20:43:23.090"/>
+    <p1510:client id="{30DC239F-2007-1A92-83B7-845E0204119B}" v="15" dt="2026-06-30T15:06:29.924"/>
   </p1510:revLst>
 </p1510:revInfo>
 </file>
@@ -182,7 +183,7 @@
             </a:lvl1pPr>
           </a:lstStyle>
           <a:p>
-            <a:endParaRPr lang="en-US"/>
+            <a:endParaRPr lang="en-GB"/>
           </a:p>
         </p:txBody>
       </p:sp>
@@ -213,10 +214,10 @@
             </a:lvl1pPr>
           </a:lstStyle>
           <a:p>
-            <a:fld id="{996B7518-7C4A-4CD2-ACB5-0B2CC3B3464E}" type="datetimeFigureOut">
-              <a:t>6/18/2026</a:t>
+            <a:fld id="{99B5B60E-CD05-455A-93EC-2D6ADCB3B924}" type="datetimeFigureOut">
+              <a:t>30/06/2026</a:t>
             </a:fld>
-            <a:endParaRPr lang="en-US"/>
+            <a:endParaRPr lang="en-GB"/>
           </a:p>
         </p:txBody>
       </p:sp>
@@ -249,7 +250,7 @@
           <a:bodyPr vert="horz" lIns="91440" tIns="45720" rIns="91440" bIns="45720" rtlCol="0" anchor="ctr"/>
           <a:lstStyle/>
           <a:p>
-            <a:endParaRPr lang="en-US"/>
+            <a:endParaRPr lang="en-GB"/>
           </a:p>
         </p:txBody>
       </p:sp>
@@ -278,35 +279,35 @@
           <a:p>
             <a:pPr lvl="0"/>
             <a:r>
-              <a:rPr lang="en-US"/>
+              <a:rPr lang="en-GB"/>
               <a:t>Click to edit Master text styles</a:t>
             </a:r>
           </a:p>
           <a:p>
             <a:pPr lvl="1"/>
             <a:r>
-              <a:rPr lang="en-US"/>
+              <a:rPr lang="en-GB"/>
               <a:t>Second level</a:t>
             </a:r>
           </a:p>
           <a:p>
             <a:pPr lvl="2"/>
             <a:r>
-              <a:rPr lang="en-US"/>
+              <a:rPr lang="en-GB"/>
               <a:t>Third level</a:t>
             </a:r>
           </a:p>
           <a:p>
             <a:pPr lvl="3"/>
             <a:r>
-              <a:rPr lang="en-US"/>
+              <a:rPr lang="en-GB"/>
               <a:t>Fourth level</a:t>
             </a:r>
           </a:p>
           <a:p>
             <a:pPr lvl="4"/>
             <a:r>
-              <a:rPr lang="en-US"/>
+              <a:rPr lang="en-GB"/>
               <a:t>Fifth level</a:t>
             </a:r>
           </a:p>
@@ -339,7 +340,7 @@
             </a:lvl1pPr>
           </a:lstStyle>
           <a:p>
-            <a:endParaRPr lang="en-US"/>
+            <a:endParaRPr lang="en-GB"/>
           </a:p>
         </p:txBody>
       </p:sp>
@@ -370,17 +371,17 @@
             </a:lvl1pPr>
           </a:lstStyle>
           <a:p>
-            <a:fld id="{198794E3-4552-4FCD-9A4A-7A31D589EE6C}" type="slidenum">
+            <a:fld id="{F0905AA8-CF67-4B1B-B023-D2FA811F065C}" type="slidenum">
               <a:t>‹#›</a:t>
             </a:fld>
-            <a:endParaRPr lang="en-US"/>
+            <a:endParaRPr lang="en-GB"/>
           </a:p>
         </p:txBody>
       </p:sp>
     </p:spTree>
     <p:extLst>
       <p:ext uri="{BB962C8B-B14F-4D97-AF65-F5344CB8AC3E}">
-        <p14:creationId xmlns:p14="http://schemas.microsoft.com/office/powerpoint/2010/main" val="1010928020"/>
+        <p14:creationId xmlns:p14="http://schemas.microsoft.com/office/powerpoint/2010/main" val="2715243907"/>
       </p:ext>
     </p:extLst>
   </p:cSld>
@@ -761,7 +762,7 @@
           <a:p>
             <a:fld id="{F7021451-1387-4CA6-816F-3879F97B5CBC}" type="slidenum">
               <a:rPr lang="en-US"/>
-              <a:t>12</a:t>
+              <a:t>13</a:t>
             </a:fld>
             <a:endParaRPr lang="en-US"/>
           </a:p>
@@ -1638,10 +1639,10 @@
           </a:lstStyle>
           <a:p>
             <a:r>
-              <a:rPr lang="en-US"/>
+              <a:rPr lang="en-GB"/>
               <a:t>Click to edit Master title style</a:t>
             </a:r>
-            <a:endParaRPr lang="en-US" dirty="0"/>
+            <a:endParaRPr lang="en-GB" dirty="0"/>
           </a:p>
         </p:txBody>
       </p:sp>
@@ -1703,10 +1704,10 @@
           </a:lstStyle>
           <a:p>
             <a:r>
-              <a:rPr lang="en-US"/>
+              <a:rPr lang="en-GB"/>
               <a:t>Click to edit Master subtitle style</a:t>
             </a:r>
-            <a:endParaRPr lang="en-US" dirty="0"/>
+            <a:endParaRPr lang="en-GB" dirty="0"/>
           </a:p>
         </p:txBody>
       </p:sp>
@@ -1726,10 +1727,10 @@
           <a:lstStyle/>
           <a:p>
             <a:fld id="{846CE7D5-CF57-46EF-B807-FDD0502418D4}" type="datetimeFigureOut">
-              <a:rPr lang="en-US" smtClean="0"/>
-              <a:t>6/18/2026</a:t>
+              <a:rPr lang="en-GB" smtClean="0"/>
+              <a:t>30/06/2026</a:t>
             </a:fld>
-            <a:endParaRPr lang="en-US"/>
+            <a:endParaRPr lang="en-GB"/>
           </a:p>
         </p:txBody>
       </p:sp>
@@ -1748,7 +1749,7 @@
           <a:bodyPr/>
           <a:lstStyle/>
           <a:p>
-            <a:endParaRPr lang="en-US"/>
+            <a:endParaRPr lang="en-GB"/>
           </a:p>
         </p:txBody>
       </p:sp>
@@ -1768,10 +1769,10 @@
           <a:lstStyle/>
           <a:p>
             <a:fld id="{330EA680-D336-4FF7-8B7A-9848BB0A1C32}" type="slidenum">
-              <a:rPr lang="en-US" smtClean="0"/>
+              <a:rPr lang="en-GB" smtClean="0"/>
               <a:t>‹#›</a:t>
             </a:fld>
-            <a:endParaRPr lang="en-US"/>
+            <a:endParaRPr lang="en-GB"/>
           </a:p>
         </p:txBody>
       </p:sp>
@@ -1821,10 +1822,10 @@
           <a:lstStyle/>
           <a:p>
             <a:r>
-              <a:rPr lang="en-US"/>
+              <a:rPr lang="en-GB"/>
               <a:t>Click to edit Master title style</a:t>
             </a:r>
-            <a:endParaRPr lang="en-US" dirty="0"/>
+            <a:endParaRPr lang="en-GB" dirty="0"/>
           </a:p>
         </p:txBody>
       </p:sp>
@@ -1845,38 +1846,38 @@
           <a:p>
             <a:pPr lvl="0"/>
             <a:r>
-              <a:rPr lang="en-US"/>
+              <a:rPr lang="en-GB"/>
               <a:t>Click to edit Master text styles</a:t>
             </a:r>
           </a:p>
           <a:p>
             <a:pPr lvl="1"/>
             <a:r>
-              <a:rPr lang="en-US"/>
+              <a:rPr lang="en-GB"/>
               <a:t>Second level</a:t>
             </a:r>
           </a:p>
           <a:p>
             <a:pPr lvl="2"/>
             <a:r>
-              <a:rPr lang="en-US"/>
+              <a:rPr lang="en-GB"/>
               <a:t>Third level</a:t>
             </a:r>
           </a:p>
           <a:p>
             <a:pPr lvl="3"/>
             <a:r>
-              <a:rPr lang="en-US"/>
+              <a:rPr lang="en-GB"/>
               <a:t>Fourth level</a:t>
             </a:r>
           </a:p>
           <a:p>
             <a:pPr lvl="4"/>
             <a:r>
-              <a:rPr lang="en-US"/>
+              <a:rPr lang="en-GB"/>
               <a:t>Fifth level</a:t>
             </a:r>
-            <a:endParaRPr lang="en-US" dirty="0"/>
+            <a:endParaRPr lang="en-GB" dirty="0"/>
           </a:p>
         </p:txBody>
       </p:sp>
@@ -1896,10 +1897,10 @@
           <a:lstStyle/>
           <a:p>
             <a:fld id="{846CE7D5-CF57-46EF-B807-FDD0502418D4}" type="datetimeFigureOut">
-              <a:rPr lang="en-US" smtClean="0"/>
-              <a:t>6/18/2026</a:t>
+              <a:rPr lang="en-GB" smtClean="0"/>
+              <a:t>30/06/2026</a:t>
             </a:fld>
-            <a:endParaRPr lang="en-US"/>
+            <a:endParaRPr lang="en-GB"/>
           </a:p>
         </p:txBody>
       </p:sp>
@@ -1918,7 +1919,7 @@
           <a:bodyPr/>
           <a:lstStyle/>
           <a:p>
-            <a:endParaRPr lang="en-US"/>
+            <a:endParaRPr lang="en-GB"/>
           </a:p>
         </p:txBody>
       </p:sp>
@@ -1938,10 +1939,10 @@
           <a:lstStyle/>
           <a:p>
             <a:fld id="{330EA680-D336-4FF7-8B7A-9848BB0A1C32}" type="slidenum">
-              <a:rPr lang="en-US" smtClean="0"/>
+              <a:rPr lang="en-GB" smtClean="0"/>
               <a:t>‹#›</a:t>
             </a:fld>
-            <a:endParaRPr lang="en-US"/>
+            <a:endParaRPr lang="en-GB"/>
           </a:p>
         </p:txBody>
       </p:sp>
@@ -1996,10 +1997,10 @@
           <a:lstStyle/>
           <a:p>
             <a:r>
-              <a:rPr lang="en-US"/>
+              <a:rPr lang="en-GB"/>
               <a:t>Click to edit Master title style</a:t>
             </a:r>
-            <a:endParaRPr lang="en-US" dirty="0"/>
+            <a:endParaRPr lang="en-GB" dirty="0"/>
           </a:p>
         </p:txBody>
       </p:sp>
@@ -2025,38 +2026,38 @@
           <a:p>
             <a:pPr lvl="0"/>
             <a:r>
-              <a:rPr lang="en-US"/>
+              <a:rPr lang="en-GB"/>
               <a:t>Click to edit Master text styles</a:t>
             </a:r>
           </a:p>
           <a:p>
             <a:pPr lvl="1"/>
             <a:r>
-              <a:rPr lang="en-US"/>
+              <a:rPr lang="en-GB"/>
               <a:t>Second level</a:t>
             </a:r>
           </a:p>
           <a:p>
             <a:pPr lvl="2"/>
             <a:r>
-              <a:rPr lang="en-US"/>
+              <a:rPr lang="en-GB"/>
               <a:t>Third level</a:t>
             </a:r>
           </a:p>
           <a:p>
             <a:pPr lvl="3"/>
             <a:r>
-              <a:rPr lang="en-US"/>
+              <a:rPr lang="en-GB"/>
               <a:t>Fourth level</a:t>
             </a:r>
           </a:p>
           <a:p>
             <a:pPr lvl="4"/>
             <a:r>
-              <a:rPr lang="en-US"/>
+              <a:rPr lang="en-GB"/>
               <a:t>Fifth level</a:t>
             </a:r>
-            <a:endParaRPr lang="en-US" dirty="0"/>
+            <a:endParaRPr lang="en-GB" dirty="0"/>
           </a:p>
         </p:txBody>
       </p:sp>
@@ -2076,10 +2077,10 @@
           <a:lstStyle/>
           <a:p>
             <a:fld id="{846CE7D5-CF57-46EF-B807-FDD0502418D4}" type="datetimeFigureOut">
-              <a:rPr lang="en-US" smtClean="0"/>
-              <a:t>6/18/2026</a:t>
+              <a:rPr lang="en-GB" smtClean="0"/>
+              <a:t>30/06/2026</a:t>
             </a:fld>
-            <a:endParaRPr lang="en-US"/>
+            <a:endParaRPr lang="en-GB"/>
           </a:p>
         </p:txBody>
       </p:sp>
@@ -2098,7 +2099,7 @@
           <a:bodyPr/>
           <a:lstStyle/>
           <a:p>
-            <a:endParaRPr lang="en-US"/>
+            <a:endParaRPr lang="en-GB"/>
           </a:p>
         </p:txBody>
       </p:sp>
@@ -2118,10 +2119,10 @@
           <a:lstStyle/>
           <a:p>
             <a:fld id="{330EA680-D336-4FF7-8B7A-9848BB0A1C32}" type="slidenum">
-              <a:rPr lang="en-US" smtClean="0"/>
+              <a:rPr lang="en-GB" smtClean="0"/>
               <a:t>‹#›</a:t>
             </a:fld>
-            <a:endParaRPr lang="en-US"/>
+            <a:endParaRPr lang="en-GB"/>
           </a:p>
         </p:txBody>
       </p:sp>
@@ -2163,7 +2164,178 @@
     </p:spTree>
     <p:extLst>
       <p:ext uri="{BB962C8B-B14F-4D97-AF65-F5344CB8AC3E}">
-        <p14:creationId xmlns:p14="http://schemas.microsoft.com/office/powerpoint/2010/main" val="1321492319"/>
+        <p14:creationId xmlns:p14="http://schemas.microsoft.com/office/powerpoint/2010/main" val="1137211588"/>
+      </p:ext>
+    </p:extLst>
+  </p:cSld>
+  <p:clrMapOvr>
+    <a:masterClrMapping/>
+  </p:clrMapOvr>
+</p:sldLayout>
+</file>
+
+<file path=ppt/slideLayouts/slideLayout13.xml><?xml version="1.0" encoding="utf-8"?>
+<p:sldLayout xmlns:a="http://schemas.openxmlformats.org/drawingml/2006/main" xmlns:r="http://schemas.openxmlformats.org/officeDocument/2006/relationships" xmlns:p="http://schemas.openxmlformats.org/presentationml/2006/main" showMasterSp="0" preserve="1" userDrawn="1">
+  <p:cSld name="5_Title and Content">
+    <p:bg>
+      <p:bgPr>
+        <a:blipFill dpi="0" rotWithShape="1">
+          <a:blip r:embed="rId2">
+            <a:lum/>
+          </a:blip>
+          <a:srcRect/>
+          <a:stretch>
+            <a:fillRect/>
+          </a:stretch>
+        </a:blipFill>
+        <a:effectLst/>
+      </p:bgPr>
+    </p:bg>
+    <p:spTree>
+      <p:nvGrpSpPr>
+        <p:cNvPr id="1" name=""/>
+        <p:cNvGrpSpPr/>
+        <p:nvPr/>
+      </p:nvGrpSpPr>
+      <p:grpSpPr>
+        <a:xfrm>
+          <a:off x="0" y="0"/>
+          <a:ext cx="0" cy="0"/>
+          <a:chOff x="0" y="0"/>
+          <a:chExt cx="0" cy="0"/>
+        </a:xfrm>
+      </p:grpSpPr>
+      <p:sp>
+        <p:nvSpPr>
+          <p:cNvPr id="3" name="Content Placeholder 2"/>
+          <p:cNvSpPr>
+            <a:spLocks noGrp="1"/>
+          </p:cNvSpPr>
+          <p:nvPr>
+            <p:ph idx="1"/>
+          </p:nvPr>
+        </p:nvSpPr>
+        <p:spPr>
+          <a:xfrm>
+            <a:off x="1680000" y="1920001"/>
+            <a:ext cx="9886499" cy="4389320"/>
+          </a:xfrm>
+        </p:spPr>
+        <p:txBody>
+          <a:bodyPr/>
+          <a:lstStyle>
+            <a:lvl1pPr marL="457189" indent="-457189">
+              <a:buClr>
+                <a:srgbClr val="10CF53"/>
+              </a:buClr>
+              <a:buFont typeface="Wingdings" pitchFamily="2" charset="2"/>
+              <a:buChar char="§"/>
+              <a:defRPr/>
+            </a:lvl1pPr>
+            <a:lvl2pPr marL="698480" indent="-457189">
+              <a:buClr>
+                <a:srgbClr val="10CF53"/>
+              </a:buClr>
+              <a:buFont typeface="Wingdings" pitchFamily="2" charset="2"/>
+              <a:buChar char="§"/>
+              <a:defRPr/>
+            </a:lvl2pPr>
+            <a:lvl3pPr marL="922840" indent="-457189">
+              <a:buClr>
+                <a:srgbClr val="10CF53"/>
+              </a:buClr>
+              <a:buFont typeface="Wingdings" pitchFamily="2" charset="2"/>
+              <a:buChar char="§"/>
+              <a:defRPr/>
+            </a:lvl3pPr>
+            <a:lvl4pPr marL="950351" indent="-230710">
+              <a:buClr>
+                <a:srgbClr val="C9122B"/>
+              </a:buClr>
+              <a:buFont typeface="Wingdings" panose="05000000000000000000" pitchFamily="2" charset="2"/>
+              <a:buChar char="§"/>
+              <a:defRPr sz="2400"/>
+            </a:lvl4pPr>
+            <a:lvl5pPr marL="1197991" indent="-245525">
+              <a:buClr>
+                <a:srgbClr val="C9122B"/>
+              </a:buClr>
+              <a:buFont typeface="Wingdings" panose="05000000000000000000" pitchFamily="2" charset="2"/>
+              <a:buChar char="§"/>
+              <a:defRPr sz="2400"/>
+            </a:lvl5pPr>
+          </a:lstStyle>
+          <a:p>
+            <a:pPr lvl="0"/>
+            <a:r>
+              <a:rPr lang="en-US"/>
+              <a:t>Click to edit Master text styles</a:t>
+            </a:r>
+          </a:p>
+          <a:p>
+            <a:pPr lvl="1"/>
+            <a:r>
+              <a:rPr lang="en-US"/>
+              <a:t>Second level</a:t>
+            </a:r>
+          </a:p>
+          <a:p>
+            <a:pPr lvl="2"/>
+            <a:r>
+              <a:rPr lang="en-US"/>
+              <a:t>Third level</a:t>
+            </a:r>
+          </a:p>
+        </p:txBody>
+      </p:sp>
+      <p:sp>
+        <p:nvSpPr>
+          <p:cNvPr id="2" name="Title 1">
+            <a:extLst>
+              <a:ext uri="{FF2B5EF4-FFF2-40B4-BE49-F238E27FC236}">
+                <a16:creationId xmlns:a16="http://schemas.microsoft.com/office/drawing/2014/main" id="{3BD1F0D6-76E2-826C-A0FA-FA6540F7A516}"/>
+              </a:ext>
+            </a:extLst>
+          </p:cNvPr>
+          <p:cNvSpPr>
+            <a:spLocks noGrp="1"/>
+          </p:cNvSpPr>
+          <p:nvPr>
+            <p:ph type="title"/>
+          </p:nvPr>
+        </p:nvSpPr>
+        <p:spPr>
+          <a:xfrm>
+            <a:off x="1680000" y="681600"/>
+            <a:ext cx="9886499" cy="1115219"/>
+          </a:xfrm>
+        </p:spPr>
+        <p:txBody>
+          <a:bodyPr/>
+          <a:lstStyle>
+            <a:lvl1pPr>
+              <a:defRPr b="1" i="0">
+                <a:solidFill>
+                  <a:schemeClr val="tx1"/>
+                </a:solidFill>
+                <a:latin typeface="Arial" charset="0"/>
+                <a:ea typeface="Arial" charset="0"/>
+                <a:cs typeface="Arial" charset="0"/>
+              </a:defRPr>
+            </a:lvl1pPr>
+          </a:lstStyle>
+          <a:p>
+            <a:r>
+              <a:rPr lang="en-US"/>
+              <a:t>Click to edit Master title style</a:t>
+            </a:r>
+          </a:p>
+        </p:txBody>
+      </p:sp>
+    </p:spTree>
+    <p:extLst>
+      <p:ext uri="{BB962C8B-B14F-4D97-AF65-F5344CB8AC3E}">
+        <p14:creationId xmlns:p14="http://schemas.microsoft.com/office/powerpoint/2010/main" val="2419961383"/>
       </p:ext>
     </p:extLst>
   </p:cSld>
@@ -2206,10 +2378,10 @@
           <a:lstStyle/>
           <a:p>
             <a:r>
-              <a:rPr lang="en-US"/>
+              <a:rPr lang="en-GB"/>
               <a:t>Click to edit Master title style</a:t>
             </a:r>
-            <a:endParaRPr lang="en-US" dirty="0"/>
+            <a:endParaRPr lang="en-GB" dirty="0"/>
           </a:p>
         </p:txBody>
       </p:sp>
@@ -2230,38 +2402,38 @@
           <a:p>
             <a:pPr lvl="0"/>
             <a:r>
-              <a:rPr lang="en-US"/>
+              <a:rPr lang="en-GB"/>
               <a:t>Click to edit Master text styles</a:t>
             </a:r>
           </a:p>
           <a:p>
             <a:pPr lvl="1"/>
             <a:r>
-              <a:rPr lang="en-US"/>
+              <a:rPr lang="en-GB"/>
               <a:t>Second level</a:t>
             </a:r>
           </a:p>
           <a:p>
             <a:pPr lvl="2"/>
             <a:r>
-              <a:rPr lang="en-US"/>
+              <a:rPr lang="en-GB"/>
               <a:t>Third level</a:t>
             </a:r>
           </a:p>
           <a:p>
             <a:pPr lvl="3"/>
             <a:r>
-              <a:rPr lang="en-US"/>
+              <a:rPr lang="en-GB"/>
               <a:t>Fourth level</a:t>
             </a:r>
           </a:p>
           <a:p>
             <a:pPr lvl="4"/>
             <a:r>
-              <a:rPr lang="en-US"/>
+              <a:rPr lang="en-GB"/>
               <a:t>Fifth level</a:t>
             </a:r>
-            <a:endParaRPr lang="en-US" dirty="0"/>
+            <a:endParaRPr lang="en-GB" dirty="0"/>
           </a:p>
         </p:txBody>
       </p:sp>
@@ -2281,10 +2453,10 @@
           <a:lstStyle/>
           <a:p>
             <a:fld id="{846CE7D5-CF57-46EF-B807-FDD0502418D4}" type="datetimeFigureOut">
-              <a:rPr lang="en-US" smtClean="0"/>
-              <a:t>6/18/2026</a:t>
+              <a:rPr lang="en-GB" smtClean="0"/>
+              <a:t>30/06/2026</a:t>
             </a:fld>
-            <a:endParaRPr lang="en-US"/>
+            <a:endParaRPr lang="en-GB"/>
           </a:p>
         </p:txBody>
       </p:sp>
@@ -2303,7 +2475,7 @@
           <a:bodyPr/>
           <a:lstStyle/>
           <a:p>
-            <a:endParaRPr lang="en-US"/>
+            <a:endParaRPr lang="en-GB"/>
           </a:p>
         </p:txBody>
       </p:sp>
@@ -2323,10 +2495,10 @@
           <a:lstStyle/>
           <a:p>
             <a:fld id="{330EA680-D336-4FF7-8B7A-9848BB0A1C32}" type="slidenum">
-              <a:rPr lang="en-US" smtClean="0"/>
+              <a:rPr lang="en-GB" smtClean="0"/>
               <a:t>‹#›</a:t>
             </a:fld>
-            <a:endParaRPr lang="en-US"/>
+            <a:endParaRPr lang="en-GB"/>
           </a:p>
         </p:txBody>
       </p:sp>
@@ -2385,10 +2557,10 @@
           </a:lstStyle>
           <a:p>
             <a:r>
-              <a:rPr lang="en-US"/>
+              <a:rPr lang="en-GB"/>
               <a:t>Click to edit Master title style</a:t>
             </a:r>
-            <a:endParaRPr lang="en-US" dirty="0"/>
+            <a:endParaRPr lang="en-GB" dirty="0"/>
           </a:p>
         </p:txBody>
       </p:sp>
@@ -2505,7 +2677,7 @@
           <a:p>
             <a:pPr lvl="0"/>
             <a:r>
-              <a:rPr lang="en-US"/>
+              <a:rPr lang="en-GB"/>
               <a:t>Click to edit Master text styles</a:t>
             </a:r>
           </a:p>
@@ -2527,10 +2699,10 @@
           <a:lstStyle/>
           <a:p>
             <a:fld id="{846CE7D5-CF57-46EF-B807-FDD0502418D4}" type="datetimeFigureOut">
-              <a:rPr lang="en-US" smtClean="0"/>
-              <a:t>6/18/2026</a:t>
+              <a:rPr lang="en-GB" smtClean="0"/>
+              <a:t>30/06/2026</a:t>
             </a:fld>
-            <a:endParaRPr lang="en-US"/>
+            <a:endParaRPr lang="en-GB"/>
           </a:p>
         </p:txBody>
       </p:sp>
@@ -2549,7 +2721,7 @@
           <a:bodyPr/>
           <a:lstStyle/>
           <a:p>
-            <a:endParaRPr lang="en-US"/>
+            <a:endParaRPr lang="en-GB"/>
           </a:p>
         </p:txBody>
       </p:sp>
@@ -2569,10 +2741,10 @@
           <a:lstStyle/>
           <a:p>
             <a:fld id="{330EA680-D336-4FF7-8B7A-9848BB0A1C32}" type="slidenum">
-              <a:rPr lang="en-US" smtClean="0"/>
+              <a:rPr lang="en-GB" smtClean="0"/>
               <a:t>‹#›</a:t>
             </a:fld>
-            <a:endParaRPr lang="en-US"/>
+            <a:endParaRPr lang="en-GB"/>
           </a:p>
         </p:txBody>
       </p:sp>
@@ -2622,10 +2794,10 @@
           <a:lstStyle/>
           <a:p>
             <a:r>
-              <a:rPr lang="en-US"/>
+              <a:rPr lang="en-GB"/>
               <a:t>Click to edit Master title style</a:t>
             </a:r>
-            <a:endParaRPr lang="en-US" dirty="0"/>
+            <a:endParaRPr lang="en-GB" dirty="0"/>
           </a:p>
         </p:txBody>
       </p:sp>
@@ -2651,38 +2823,38 @@
           <a:p>
             <a:pPr lvl="0"/>
             <a:r>
-              <a:rPr lang="en-US"/>
+              <a:rPr lang="en-GB"/>
               <a:t>Click to edit Master text styles</a:t>
             </a:r>
           </a:p>
           <a:p>
             <a:pPr lvl="1"/>
             <a:r>
-              <a:rPr lang="en-US"/>
+              <a:rPr lang="en-GB"/>
               <a:t>Second level</a:t>
             </a:r>
           </a:p>
           <a:p>
             <a:pPr lvl="2"/>
             <a:r>
-              <a:rPr lang="en-US"/>
+              <a:rPr lang="en-GB"/>
               <a:t>Third level</a:t>
             </a:r>
           </a:p>
           <a:p>
             <a:pPr lvl="3"/>
             <a:r>
-              <a:rPr lang="en-US"/>
+              <a:rPr lang="en-GB"/>
               <a:t>Fourth level</a:t>
             </a:r>
           </a:p>
           <a:p>
             <a:pPr lvl="4"/>
             <a:r>
-              <a:rPr lang="en-US"/>
+              <a:rPr lang="en-GB"/>
               <a:t>Fifth level</a:t>
             </a:r>
-            <a:endParaRPr lang="en-US" dirty="0"/>
+            <a:endParaRPr lang="en-GB" dirty="0"/>
           </a:p>
         </p:txBody>
       </p:sp>
@@ -2708,38 +2880,38 @@
           <a:p>
             <a:pPr lvl="0"/>
             <a:r>
-              <a:rPr lang="en-US"/>
+              <a:rPr lang="en-GB"/>
               <a:t>Click to edit Master text styles</a:t>
             </a:r>
           </a:p>
           <a:p>
             <a:pPr lvl="1"/>
             <a:r>
-              <a:rPr lang="en-US"/>
+              <a:rPr lang="en-GB"/>
               <a:t>Second level</a:t>
             </a:r>
           </a:p>
           <a:p>
             <a:pPr lvl="2"/>
             <a:r>
-              <a:rPr lang="en-US"/>
+              <a:rPr lang="en-GB"/>
               <a:t>Third level</a:t>
             </a:r>
           </a:p>
           <a:p>
             <a:pPr lvl="3"/>
             <a:r>
-              <a:rPr lang="en-US"/>
+              <a:rPr lang="en-GB"/>
               <a:t>Fourth level</a:t>
             </a:r>
           </a:p>
           <a:p>
             <a:pPr lvl="4"/>
             <a:r>
-              <a:rPr lang="en-US"/>
+              <a:rPr lang="en-GB"/>
               <a:t>Fifth level</a:t>
             </a:r>
-            <a:endParaRPr lang="en-US" dirty="0"/>
+            <a:endParaRPr lang="en-GB" dirty="0"/>
           </a:p>
         </p:txBody>
       </p:sp>
@@ -2759,10 +2931,10 @@
           <a:lstStyle/>
           <a:p>
             <a:fld id="{846CE7D5-CF57-46EF-B807-FDD0502418D4}" type="datetimeFigureOut">
-              <a:rPr lang="en-US" smtClean="0"/>
-              <a:t>6/18/2026</a:t>
+              <a:rPr lang="en-GB" smtClean="0"/>
+              <a:t>30/06/2026</a:t>
             </a:fld>
-            <a:endParaRPr lang="en-US"/>
+            <a:endParaRPr lang="en-GB"/>
           </a:p>
         </p:txBody>
       </p:sp>
@@ -2781,7 +2953,7 @@
           <a:bodyPr/>
           <a:lstStyle/>
           <a:p>
-            <a:endParaRPr lang="en-US"/>
+            <a:endParaRPr lang="en-GB"/>
           </a:p>
         </p:txBody>
       </p:sp>
@@ -2801,10 +2973,10 @@
           <a:lstStyle/>
           <a:p>
             <a:fld id="{330EA680-D336-4FF7-8B7A-9848BB0A1C32}" type="slidenum">
-              <a:rPr lang="en-US" smtClean="0"/>
+              <a:rPr lang="en-GB" smtClean="0"/>
               <a:t>‹#›</a:t>
             </a:fld>
-            <a:endParaRPr lang="en-US"/>
+            <a:endParaRPr lang="en-GB"/>
           </a:p>
         </p:txBody>
       </p:sp>
@@ -2859,10 +3031,10 @@
           <a:lstStyle/>
           <a:p>
             <a:r>
-              <a:rPr lang="en-US"/>
+              <a:rPr lang="en-GB"/>
               <a:t>Click to edit Master title style</a:t>
             </a:r>
-            <a:endParaRPr lang="en-US" dirty="0"/>
+            <a:endParaRPr lang="en-GB" dirty="0"/>
           </a:p>
         </p:txBody>
       </p:sp>
@@ -2925,7 +3097,7 @@
           <a:p>
             <a:pPr lvl="0"/>
             <a:r>
-              <a:rPr lang="en-US"/>
+              <a:rPr lang="en-GB"/>
               <a:t>Click to edit Master text styles</a:t>
             </a:r>
           </a:p>
@@ -2953,38 +3125,38 @@
           <a:p>
             <a:pPr lvl="0"/>
             <a:r>
-              <a:rPr lang="en-US"/>
+              <a:rPr lang="en-GB"/>
               <a:t>Click to edit Master text styles</a:t>
             </a:r>
           </a:p>
           <a:p>
             <a:pPr lvl="1"/>
             <a:r>
-              <a:rPr lang="en-US"/>
+              <a:rPr lang="en-GB"/>
               <a:t>Second level</a:t>
             </a:r>
           </a:p>
           <a:p>
             <a:pPr lvl="2"/>
             <a:r>
-              <a:rPr lang="en-US"/>
+              <a:rPr lang="en-GB"/>
               <a:t>Third level</a:t>
             </a:r>
           </a:p>
           <a:p>
             <a:pPr lvl="3"/>
             <a:r>
-              <a:rPr lang="en-US"/>
+              <a:rPr lang="en-GB"/>
               <a:t>Fourth level</a:t>
             </a:r>
           </a:p>
           <a:p>
             <a:pPr lvl="4"/>
             <a:r>
-              <a:rPr lang="en-US"/>
+              <a:rPr lang="en-GB"/>
               <a:t>Fifth level</a:t>
             </a:r>
-            <a:endParaRPr lang="en-US" dirty="0"/>
+            <a:endParaRPr lang="en-GB" dirty="0"/>
           </a:p>
         </p:txBody>
       </p:sp>
@@ -3047,7 +3219,7 @@
           <a:p>
             <a:pPr lvl="0"/>
             <a:r>
-              <a:rPr lang="en-US"/>
+              <a:rPr lang="en-GB"/>
               <a:t>Click to edit Master text styles</a:t>
             </a:r>
           </a:p>
@@ -3075,38 +3247,38 @@
           <a:p>
             <a:pPr lvl="0"/>
             <a:r>
-              <a:rPr lang="en-US"/>
+              <a:rPr lang="en-GB"/>
               <a:t>Click to edit Master text styles</a:t>
             </a:r>
           </a:p>
           <a:p>
             <a:pPr lvl="1"/>
             <a:r>
-              <a:rPr lang="en-US"/>
+              <a:rPr lang="en-GB"/>
               <a:t>Second level</a:t>
             </a:r>
           </a:p>
           <a:p>
             <a:pPr lvl="2"/>
             <a:r>
-              <a:rPr lang="en-US"/>
+              <a:rPr lang="en-GB"/>
               <a:t>Third level</a:t>
             </a:r>
           </a:p>
           <a:p>
             <a:pPr lvl="3"/>
             <a:r>
-              <a:rPr lang="en-US"/>
+              <a:rPr lang="en-GB"/>
               <a:t>Fourth level</a:t>
             </a:r>
           </a:p>
           <a:p>
             <a:pPr lvl="4"/>
             <a:r>
-              <a:rPr lang="en-US"/>
+              <a:rPr lang="en-GB"/>
               <a:t>Fifth level</a:t>
             </a:r>
-            <a:endParaRPr lang="en-US" dirty="0"/>
+            <a:endParaRPr lang="en-GB" dirty="0"/>
           </a:p>
         </p:txBody>
       </p:sp>
@@ -3126,10 +3298,10 @@
           <a:lstStyle/>
           <a:p>
             <a:fld id="{846CE7D5-CF57-46EF-B807-FDD0502418D4}" type="datetimeFigureOut">
-              <a:rPr lang="en-US" smtClean="0"/>
-              <a:t>6/18/2026</a:t>
+              <a:rPr lang="en-GB" smtClean="0"/>
+              <a:t>30/06/2026</a:t>
             </a:fld>
-            <a:endParaRPr lang="en-US"/>
+            <a:endParaRPr lang="en-GB"/>
           </a:p>
         </p:txBody>
       </p:sp>
@@ -3148,7 +3320,7 @@
           <a:bodyPr/>
           <a:lstStyle/>
           <a:p>
-            <a:endParaRPr lang="en-US"/>
+            <a:endParaRPr lang="en-GB"/>
           </a:p>
         </p:txBody>
       </p:sp>
@@ -3168,10 +3340,10 @@
           <a:lstStyle/>
           <a:p>
             <a:fld id="{330EA680-D336-4FF7-8B7A-9848BB0A1C32}" type="slidenum">
-              <a:rPr lang="en-US" smtClean="0"/>
+              <a:rPr lang="en-GB" smtClean="0"/>
               <a:t>‹#›</a:t>
             </a:fld>
-            <a:endParaRPr lang="en-US"/>
+            <a:endParaRPr lang="en-GB"/>
           </a:p>
         </p:txBody>
       </p:sp>
@@ -3221,10 +3393,10 @@
           <a:lstStyle/>
           <a:p>
             <a:r>
-              <a:rPr lang="en-US"/>
+              <a:rPr lang="en-GB"/>
               <a:t>Click to edit Master title style</a:t>
             </a:r>
-            <a:endParaRPr lang="en-US" dirty="0"/>
+            <a:endParaRPr lang="en-GB" dirty="0"/>
           </a:p>
         </p:txBody>
       </p:sp>
@@ -3244,10 +3416,10 @@
           <a:lstStyle/>
           <a:p>
             <a:fld id="{846CE7D5-CF57-46EF-B807-FDD0502418D4}" type="datetimeFigureOut">
-              <a:rPr lang="en-US" smtClean="0"/>
-              <a:t>6/18/2026</a:t>
+              <a:rPr lang="en-GB" smtClean="0"/>
+              <a:t>30/06/2026</a:t>
             </a:fld>
-            <a:endParaRPr lang="en-US"/>
+            <a:endParaRPr lang="en-GB"/>
           </a:p>
         </p:txBody>
       </p:sp>
@@ -3266,7 +3438,7 @@
           <a:bodyPr/>
           <a:lstStyle/>
           <a:p>
-            <a:endParaRPr lang="en-US"/>
+            <a:endParaRPr lang="en-GB"/>
           </a:p>
         </p:txBody>
       </p:sp>
@@ -3286,10 +3458,10 @@
           <a:lstStyle/>
           <a:p>
             <a:fld id="{330EA680-D336-4FF7-8B7A-9848BB0A1C32}" type="slidenum">
-              <a:rPr lang="en-US" smtClean="0"/>
+              <a:rPr lang="en-GB" smtClean="0"/>
               <a:t>‹#›</a:t>
             </a:fld>
-            <a:endParaRPr lang="en-US"/>
+            <a:endParaRPr lang="en-GB"/>
           </a:p>
         </p:txBody>
       </p:sp>
@@ -3339,10 +3511,10 @@
           <a:lstStyle/>
           <a:p>
             <a:fld id="{846CE7D5-CF57-46EF-B807-FDD0502418D4}" type="datetimeFigureOut">
-              <a:rPr lang="en-US" smtClean="0"/>
-              <a:t>6/18/2026</a:t>
+              <a:rPr lang="en-GB" smtClean="0"/>
+              <a:t>30/06/2026</a:t>
             </a:fld>
-            <a:endParaRPr lang="en-US"/>
+            <a:endParaRPr lang="en-GB"/>
           </a:p>
         </p:txBody>
       </p:sp>
@@ -3361,7 +3533,7 @@
           <a:bodyPr/>
           <a:lstStyle/>
           <a:p>
-            <a:endParaRPr lang="en-US"/>
+            <a:endParaRPr lang="en-GB"/>
           </a:p>
         </p:txBody>
       </p:sp>
@@ -3381,10 +3553,10 @@
           <a:lstStyle/>
           <a:p>
             <a:fld id="{330EA680-D336-4FF7-8B7A-9848BB0A1C32}" type="slidenum">
-              <a:rPr lang="en-US" smtClean="0"/>
+              <a:rPr lang="en-GB" smtClean="0"/>
               <a:t>‹#›</a:t>
             </a:fld>
-            <a:endParaRPr lang="en-US"/>
+            <a:endParaRPr lang="en-GB"/>
           </a:p>
         </p:txBody>
       </p:sp>
@@ -3443,10 +3615,10 @@
           </a:lstStyle>
           <a:p>
             <a:r>
-              <a:rPr lang="en-US"/>
+              <a:rPr lang="en-GB"/>
               <a:t>Click to edit Master title style</a:t>
             </a:r>
-            <a:endParaRPr lang="en-US" dirty="0"/>
+            <a:endParaRPr lang="en-GB" dirty="0"/>
           </a:p>
         </p:txBody>
       </p:sp>
@@ -3500,38 +3672,38 @@
           <a:p>
             <a:pPr lvl="0"/>
             <a:r>
-              <a:rPr lang="en-US"/>
+              <a:rPr lang="en-GB"/>
               <a:t>Click to edit Master text styles</a:t>
             </a:r>
           </a:p>
           <a:p>
             <a:pPr lvl="1"/>
             <a:r>
-              <a:rPr lang="en-US"/>
+              <a:rPr lang="en-GB"/>
               <a:t>Second level</a:t>
             </a:r>
           </a:p>
           <a:p>
             <a:pPr lvl="2"/>
             <a:r>
-              <a:rPr lang="en-US"/>
+              <a:rPr lang="en-GB"/>
               <a:t>Third level</a:t>
             </a:r>
           </a:p>
           <a:p>
             <a:pPr lvl="3"/>
             <a:r>
-              <a:rPr lang="en-US"/>
+              <a:rPr lang="en-GB"/>
               <a:t>Fourth level</a:t>
             </a:r>
           </a:p>
           <a:p>
             <a:pPr lvl="4"/>
             <a:r>
-              <a:rPr lang="en-US"/>
+              <a:rPr lang="en-GB"/>
               <a:t>Fifth level</a:t>
             </a:r>
-            <a:endParaRPr lang="en-US" dirty="0"/>
+            <a:endParaRPr lang="en-GB" dirty="0"/>
           </a:p>
         </p:txBody>
       </p:sp>
@@ -3594,7 +3766,7 @@
           <a:p>
             <a:pPr lvl="0"/>
             <a:r>
-              <a:rPr lang="en-US"/>
+              <a:rPr lang="en-GB"/>
               <a:t>Click to edit Master text styles</a:t>
             </a:r>
           </a:p>
@@ -3616,10 +3788,10 @@
           <a:lstStyle/>
           <a:p>
             <a:fld id="{846CE7D5-CF57-46EF-B807-FDD0502418D4}" type="datetimeFigureOut">
-              <a:rPr lang="en-US" smtClean="0"/>
-              <a:t>6/18/2026</a:t>
+              <a:rPr lang="en-GB" smtClean="0"/>
+              <a:t>30/06/2026</a:t>
             </a:fld>
-            <a:endParaRPr lang="en-US"/>
+            <a:endParaRPr lang="en-GB"/>
           </a:p>
         </p:txBody>
       </p:sp>
@@ -3638,7 +3810,7 @@
           <a:bodyPr/>
           <a:lstStyle/>
           <a:p>
-            <a:endParaRPr lang="en-US"/>
+            <a:endParaRPr lang="en-GB"/>
           </a:p>
         </p:txBody>
       </p:sp>
@@ -3658,10 +3830,10 @@
           <a:lstStyle/>
           <a:p>
             <a:fld id="{330EA680-D336-4FF7-8B7A-9848BB0A1C32}" type="slidenum">
-              <a:rPr lang="en-US" smtClean="0"/>
+              <a:rPr lang="en-GB" smtClean="0"/>
               <a:t>‹#›</a:t>
             </a:fld>
-            <a:endParaRPr lang="en-US"/>
+            <a:endParaRPr lang="en-GB"/>
           </a:p>
         </p:txBody>
       </p:sp>
@@ -3720,10 +3892,10 @@
           </a:lstStyle>
           <a:p>
             <a:r>
-              <a:rPr lang="en-US"/>
+              <a:rPr lang="en-GB"/>
               <a:t>Click to edit Master title style</a:t>
             </a:r>
-            <a:endParaRPr lang="en-US" dirty="0"/>
+            <a:endParaRPr lang="en-GB" dirty="0"/>
           </a:p>
         </p:txBody>
       </p:sp>
@@ -3785,10 +3957,10 @@
           </a:lstStyle>
           <a:p>
             <a:r>
-              <a:rPr lang="en-US"/>
+              <a:rPr lang="en-GB"/>
               <a:t>Click icon to add picture</a:t>
             </a:r>
-            <a:endParaRPr lang="en-US" dirty="0"/>
+            <a:endParaRPr lang="en-GB" dirty="0"/>
           </a:p>
         </p:txBody>
       </p:sp>
@@ -3851,7 +4023,7 @@
           <a:p>
             <a:pPr lvl="0"/>
             <a:r>
-              <a:rPr lang="en-US"/>
+              <a:rPr lang="en-GB"/>
               <a:t>Click to edit Master text styles</a:t>
             </a:r>
           </a:p>
@@ -3873,10 +4045,10 @@
           <a:lstStyle/>
           <a:p>
             <a:fld id="{846CE7D5-CF57-46EF-B807-FDD0502418D4}" type="datetimeFigureOut">
-              <a:rPr lang="en-US" smtClean="0"/>
-              <a:t>6/18/2026</a:t>
+              <a:rPr lang="en-GB" smtClean="0"/>
+              <a:t>30/06/2026</a:t>
             </a:fld>
-            <a:endParaRPr lang="en-US"/>
+            <a:endParaRPr lang="en-GB"/>
           </a:p>
         </p:txBody>
       </p:sp>
@@ -3895,7 +4067,7 @@
           <a:bodyPr/>
           <a:lstStyle/>
           <a:p>
-            <a:endParaRPr lang="en-US"/>
+            <a:endParaRPr lang="en-GB"/>
           </a:p>
         </p:txBody>
       </p:sp>
@@ -3915,10 +4087,10 @@
           <a:lstStyle/>
           <a:p>
             <a:fld id="{330EA680-D336-4FF7-8B7A-9848BB0A1C32}" type="slidenum">
-              <a:rPr lang="en-US" smtClean="0"/>
+              <a:rPr lang="en-GB" smtClean="0"/>
               <a:t>‹#›</a:t>
             </a:fld>
-            <a:endParaRPr lang="en-US"/>
+            <a:endParaRPr lang="en-GB"/>
           </a:p>
         </p:txBody>
       </p:sp>
@@ -3983,10 +4155,10 @@
           <a:lstStyle/>
           <a:p>
             <a:r>
-              <a:rPr lang="en-US"/>
+              <a:rPr lang="en-GB"/>
               <a:t>Click to edit Master title style</a:t>
             </a:r>
-            <a:endParaRPr lang="en-US" dirty="0"/>
+            <a:endParaRPr lang="en-GB" dirty="0"/>
           </a:p>
         </p:txBody>
       </p:sp>
@@ -4017,38 +4189,38 @@
           <a:p>
             <a:pPr lvl="0"/>
             <a:r>
-              <a:rPr lang="en-US"/>
+              <a:rPr lang="en-GB"/>
               <a:t>Click to edit Master text styles</a:t>
             </a:r>
           </a:p>
           <a:p>
             <a:pPr lvl="1"/>
             <a:r>
-              <a:rPr lang="en-US"/>
+              <a:rPr lang="en-GB"/>
               <a:t>Second level</a:t>
             </a:r>
           </a:p>
           <a:p>
             <a:pPr lvl="2"/>
             <a:r>
-              <a:rPr lang="en-US"/>
+              <a:rPr lang="en-GB"/>
               <a:t>Third level</a:t>
             </a:r>
           </a:p>
           <a:p>
             <a:pPr lvl="3"/>
             <a:r>
-              <a:rPr lang="en-US"/>
+              <a:rPr lang="en-GB"/>
               <a:t>Fourth level</a:t>
             </a:r>
           </a:p>
           <a:p>
             <a:pPr lvl="4"/>
             <a:r>
-              <a:rPr lang="en-US"/>
+              <a:rPr lang="en-GB"/>
               <a:t>Fifth level</a:t>
             </a:r>
-            <a:endParaRPr lang="en-US" dirty="0"/>
+            <a:endParaRPr lang="en-GB" dirty="0"/>
           </a:p>
         </p:txBody>
       </p:sp>
@@ -4086,10 +4258,10 @@
           </a:lstStyle>
           <a:p>
             <a:fld id="{846CE7D5-CF57-46EF-B807-FDD0502418D4}" type="datetimeFigureOut">
-              <a:rPr lang="en-US" smtClean="0"/>
-              <a:t>6/18/2026</a:t>
+              <a:rPr lang="en-GB" smtClean="0"/>
+              <a:t>30/06/2026</a:t>
             </a:fld>
-            <a:endParaRPr lang="en-US"/>
+            <a:endParaRPr lang="en-GB"/>
           </a:p>
         </p:txBody>
       </p:sp>
@@ -4126,7 +4298,7 @@
             </a:lvl1pPr>
           </a:lstStyle>
           <a:p>
-            <a:endParaRPr lang="en-US"/>
+            <a:endParaRPr lang="en-GB"/>
           </a:p>
         </p:txBody>
       </p:sp>
@@ -4164,10 +4336,10 @@
           </a:lstStyle>
           <a:p>
             <a:fld id="{330EA680-D336-4FF7-8B7A-9848BB0A1C32}" type="slidenum">
-              <a:rPr lang="en-US" smtClean="0"/>
+              <a:rPr lang="en-GB" smtClean="0"/>
               <a:t>‹#›</a:t>
             </a:fld>
-            <a:endParaRPr lang="en-US"/>
+            <a:endParaRPr lang="en-GB"/>
           </a:p>
         </p:txBody>
       </p:sp>
@@ -4192,6 +4364,7 @@
     <p:sldLayoutId id="2147483670" r:id="rId10"/>
     <p:sldLayoutId id="2147483671" r:id="rId11"/>
     <p:sldLayoutId id="2147483672" r:id="rId12"/>
+    <p:sldLayoutId id="2147483673" r:id="rId13"/>
   </p:sldLayoutIdLst>
   <p:txStyles>
     <p:titleStyle>
@@ -4379,7 +4552,7 @@
     </p:bodyStyle>
     <p:otherStyle>
       <a:defPPr>
-        <a:defRPr lang="en-US"/>
+        <a:defRPr lang="en-GB"/>
       </a:defPPr>
       <a:lvl1pPr marL="0" algn="l" defTabSz="914400" rtl="0" eaLnBrk="1" latinLnBrk="0" hangingPunct="1">
         <a:defRPr sz="1800" kern="1200">
@@ -4746,6 +4919,255 @@
           </a:p>
         </p:txBody>
       </p:sp>
+      <p:sp>
+        <p:nvSpPr>
+          <p:cNvPr id="9" name="Text 4">
+            <a:extLst>
+              <a:ext uri="{FF2B5EF4-FFF2-40B4-BE49-F238E27FC236}">
+                <a16:creationId xmlns:a16="http://schemas.microsoft.com/office/drawing/2014/main" id="{B0972C93-0120-0B31-8481-B4775EB33A78}"/>
+              </a:ext>
+            </a:extLst>
+          </p:cNvPr>
+          <p:cNvSpPr/>
+          <p:nvPr/>
+        </p:nvSpPr>
+        <p:spPr>
+          <a:xfrm>
+            <a:off x="2715200" y="5911944"/>
+            <a:ext cx="9311335" cy="1097280"/>
+          </a:xfrm>
+          <a:prstGeom prst="rect">
+            <a:avLst/>
+          </a:prstGeom>
+          <a:noFill/>
+          <a:ln/>
+        </p:spPr>
+        <p:txBody>
+          <a:bodyPr wrap="square" lIns="0" tIns="0" rIns="0" bIns="0" rtlCol="0" anchor="ctr"/>
+          <a:lstStyle>
+            <a:defPPr>
+              <a:defRPr lang="en-US"/>
+            </a:defPPr>
+            <a:lvl1pPr marL="0" algn="l" defTabSz="914400" rtl="0" eaLnBrk="1" latinLnBrk="0" hangingPunct="1">
+              <a:defRPr sz="1800" kern="1200">
+                <a:solidFill>
+                  <a:schemeClr val="tx1"/>
+                </a:solidFill>
+                <a:latin typeface="+mn-lt"/>
+                <a:ea typeface="+mn-ea"/>
+                <a:cs typeface="+mn-cs"/>
+              </a:defRPr>
+            </a:lvl1pPr>
+            <a:lvl2pPr marL="457200" algn="l" defTabSz="914400" rtl="0" eaLnBrk="1" latinLnBrk="0" hangingPunct="1">
+              <a:defRPr sz="1800" kern="1200">
+                <a:solidFill>
+                  <a:schemeClr val="tx1"/>
+                </a:solidFill>
+                <a:latin typeface="+mn-lt"/>
+                <a:ea typeface="+mn-ea"/>
+                <a:cs typeface="+mn-cs"/>
+              </a:defRPr>
+            </a:lvl2pPr>
+            <a:lvl3pPr marL="914400" algn="l" defTabSz="914400" rtl="0" eaLnBrk="1" latinLnBrk="0" hangingPunct="1">
+              <a:defRPr sz="1800" kern="1200">
+                <a:solidFill>
+                  <a:schemeClr val="tx1"/>
+                </a:solidFill>
+                <a:latin typeface="+mn-lt"/>
+                <a:ea typeface="+mn-ea"/>
+                <a:cs typeface="+mn-cs"/>
+              </a:defRPr>
+            </a:lvl3pPr>
+            <a:lvl4pPr marL="1371600" algn="l" defTabSz="914400" rtl="0" eaLnBrk="1" latinLnBrk="0" hangingPunct="1">
+              <a:defRPr sz="1800" kern="1200">
+                <a:solidFill>
+                  <a:schemeClr val="tx1"/>
+                </a:solidFill>
+                <a:latin typeface="+mn-lt"/>
+                <a:ea typeface="+mn-ea"/>
+                <a:cs typeface="+mn-cs"/>
+              </a:defRPr>
+            </a:lvl4pPr>
+            <a:lvl5pPr marL="1828800" algn="l" defTabSz="914400" rtl="0" eaLnBrk="1" latinLnBrk="0" hangingPunct="1">
+              <a:defRPr sz="1800" kern="1200">
+                <a:solidFill>
+                  <a:schemeClr val="tx1"/>
+                </a:solidFill>
+                <a:latin typeface="+mn-lt"/>
+                <a:ea typeface="+mn-ea"/>
+                <a:cs typeface="+mn-cs"/>
+              </a:defRPr>
+            </a:lvl5pPr>
+            <a:lvl6pPr marL="2286000" algn="l" defTabSz="914400" rtl="0" eaLnBrk="1" latinLnBrk="0" hangingPunct="1">
+              <a:defRPr sz="1800" kern="1200">
+                <a:solidFill>
+                  <a:schemeClr val="tx1"/>
+                </a:solidFill>
+                <a:latin typeface="+mn-lt"/>
+                <a:ea typeface="+mn-ea"/>
+                <a:cs typeface="+mn-cs"/>
+              </a:defRPr>
+            </a:lvl6pPr>
+            <a:lvl7pPr marL="2743200" algn="l" defTabSz="914400" rtl="0" eaLnBrk="1" latinLnBrk="0" hangingPunct="1">
+              <a:defRPr sz="1800" kern="1200">
+                <a:solidFill>
+                  <a:schemeClr val="tx1"/>
+                </a:solidFill>
+                <a:latin typeface="+mn-lt"/>
+                <a:ea typeface="+mn-ea"/>
+                <a:cs typeface="+mn-cs"/>
+              </a:defRPr>
+            </a:lvl7pPr>
+            <a:lvl8pPr marL="3200400" algn="l" defTabSz="914400" rtl="0" eaLnBrk="1" latinLnBrk="0" hangingPunct="1">
+              <a:defRPr sz="1800" kern="1200">
+                <a:solidFill>
+                  <a:schemeClr val="tx1"/>
+                </a:solidFill>
+                <a:latin typeface="+mn-lt"/>
+                <a:ea typeface="+mn-ea"/>
+                <a:cs typeface="+mn-cs"/>
+              </a:defRPr>
+            </a:lvl8pPr>
+            <a:lvl9pPr marL="3657600" algn="l" defTabSz="914400" rtl="0" eaLnBrk="1" latinLnBrk="0" hangingPunct="1">
+              <a:defRPr sz="1800" kern="1200">
+                <a:solidFill>
+                  <a:schemeClr val="tx1"/>
+                </a:solidFill>
+                <a:latin typeface="+mn-lt"/>
+                <a:ea typeface="+mn-ea"/>
+                <a:cs typeface="+mn-cs"/>
+              </a:defRPr>
+            </a:lvl9pPr>
+          </a:lstStyle>
+          <a:p>
+            <a:pPr marL="0" indent="0" algn="r">
+              <a:buNone/>
+            </a:pPr>
+            <a:r>
+              <a:rPr lang="en-US" sz="1300" b="1" dirty="0">
+                <a:solidFill>
+                  <a:srgbClr val="FFE7E8"/>
+                </a:solidFill>
+                <a:latin typeface="Arial" pitchFamily="34" charset="0"/>
+                <a:ea typeface="Arial" pitchFamily="34" charset="-122"/>
+                <a:cs typeface="Arial" pitchFamily="34" charset="-120"/>
+              </a:rPr>
+              <a:t>Clinical AI Hackathon: A collaboration with the St George’s Hospital Imaging Research Group</a:t>
+            </a:r>
+          </a:p>
+          <a:p>
+            <a:pPr marL="0" indent="0" algn="r">
+              <a:buNone/>
+            </a:pPr>
+            <a:r>
+              <a:rPr lang="en-US" sz="1300" i="1" dirty="0">
+                <a:solidFill>
+                  <a:srgbClr val="FFE7E8"/>
+                </a:solidFill>
+                <a:latin typeface="Arial" pitchFamily="34" charset="0"/>
+                <a:ea typeface="Arial" pitchFamily="34" charset="-122"/>
+                <a:cs typeface="Arial" pitchFamily="34" charset="-120"/>
+              </a:rPr>
+              <a:t>Dr Anita Wale, Hitesh Patel, Eleanor Hickey, Dr George </a:t>
+            </a:r>
+            <a:r>
+              <a:rPr lang="en-US" sz="1300" i="1" dirty="0" err="1">
+                <a:solidFill>
+                  <a:srgbClr val="FFE7E8"/>
+                </a:solidFill>
+                <a:latin typeface="Arial" pitchFamily="34" charset="0"/>
+                <a:ea typeface="Arial" pitchFamily="34" charset="-122"/>
+                <a:cs typeface="Arial" pitchFamily="34" charset="-120"/>
+              </a:rPr>
+              <a:t>Hammerton</a:t>
+            </a:r>
+            <a:r>
+              <a:rPr lang="en-US" sz="1300" i="1" dirty="0">
+                <a:solidFill>
+                  <a:srgbClr val="FFE7E8"/>
+                </a:solidFill>
+                <a:latin typeface="Arial" pitchFamily="34" charset="0"/>
+                <a:ea typeface="Arial" pitchFamily="34" charset="-122"/>
+                <a:cs typeface="Arial" pitchFamily="34" charset="-120"/>
+              </a:rPr>
+              <a:t> &amp; </a:t>
+            </a:r>
+            <a:r>
+              <a:rPr lang="en-US" sz="1300" i="1" dirty="0" err="1">
+                <a:solidFill>
+                  <a:srgbClr val="FFE7E8"/>
+                </a:solidFill>
+                <a:latin typeface="Arial" pitchFamily="34" charset="0"/>
+                <a:ea typeface="Arial" pitchFamily="34" charset="-122"/>
+                <a:cs typeface="Arial" pitchFamily="34" charset="-120"/>
+              </a:rPr>
+              <a:t>Mukisa</a:t>
+            </a:r>
+            <a:r>
+              <a:rPr lang="en-US" sz="1300" i="1" dirty="0">
+                <a:solidFill>
+                  <a:srgbClr val="FFE7E8"/>
+                </a:solidFill>
+                <a:latin typeface="Arial" pitchFamily="34" charset="0"/>
+                <a:ea typeface="Arial" pitchFamily="34" charset="-122"/>
+                <a:cs typeface="Arial" pitchFamily="34" charset="-120"/>
+              </a:rPr>
+              <a:t> </a:t>
+            </a:r>
+            <a:r>
+              <a:rPr lang="en-US" sz="1300" i="1" dirty="0" err="1">
+                <a:solidFill>
+                  <a:srgbClr val="FFE7E8"/>
+                </a:solidFill>
+                <a:latin typeface="Arial" pitchFamily="34" charset="0"/>
+                <a:ea typeface="Arial" pitchFamily="34" charset="-122"/>
+                <a:cs typeface="Arial" pitchFamily="34" charset="-120"/>
+              </a:rPr>
+              <a:t>Scarinzi</a:t>
+            </a:r>
+            <a:r>
+              <a:rPr lang="en-US" sz="1300" i="1" dirty="0">
+                <a:solidFill>
+                  <a:srgbClr val="FFE7E8"/>
+                </a:solidFill>
+                <a:latin typeface="Arial" pitchFamily="34" charset="0"/>
+                <a:ea typeface="Arial" pitchFamily="34" charset="-122"/>
+                <a:cs typeface="Arial" pitchFamily="34" charset="-120"/>
+              </a:rPr>
+              <a:t>  </a:t>
+            </a:r>
+          </a:p>
+        </p:txBody>
+      </p:sp>
+      <p:pic>
+        <p:nvPicPr>
+          <p:cNvPr id="10" name="Picture 9">
+            <a:extLst>
+              <a:ext uri="{FF2B5EF4-FFF2-40B4-BE49-F238E27FC236}">
+                <a16:creationId xmlns:a16="http://schemas.microsoft.com/office/drawing/2014/main" id="{141A243B-3365-C627-27C2-AFB56F09A068}"/>
+              </a:ext>
+            </a:extLst>
+          </p:cNvPr>
+          <p:cNvPicPr>
+            <a:picLocks noChangeAspect="1"/>
+          </p:cNvPicPr>
+          <p:nvPr/>
+        </p:nvPicPr>
+        <p:blipFill>
+          <a:blip r:embed="rId4"/>
+          <a:srcRect b="17602"/>
+          <a:stretch/>
+        </p:blipFill>
+        <p:spPr>
+          <a:xfrm>
+            <a:off x="-38523" y="6059606"/>
+            <a:ext cx="2325969" cy="824123"/>
+          </a:xfrm>
+          <a:prstGeom prst="rect">
+            <a:avLst/>
+          </a:prstGeom>
+        </p:spPr>
+      </p:pic>
     </p:spTree>
   </p:cSld>
   <p:clrMapOvr>
@@ -5076,7 +5498,7 @@
             <a:pPr marL="0" indent="0" algn="ctr">
               <a:buNone/>
             </a:pPr>
-            <a:endParaRPr lang="en-US" sz="1800" b="1" dirty="0">
+            <a:endParaRPr lang="en-US" sz="1800" b="1">
               <a:solidFill>
                 <a:srgbClr val="B5A9A1"/>
               </a:solidFill>
@@ -5146,31 +5568,13 @@
               </a:spcAft>
             </a:pPr>
             <a:r>
-              <a:rPr lang="en-US" dirty="0">
+              <a:rPr lang="en-US">
                 <a:solidFill>
                   <a:srgbClr val="000000"/>
                 </a:solidFill>
                 <a:cs typeface="Arial"/>
               </a:rPr>
-              <a:t>Solutions are much easier to write </a:t>
-            </a:r>
-            <a:r>
-              <a:rPr lang="en-US">
-                <a:solidFill>
-                  <a:srgbClr val="000000"/>
-                </a:solidFill>
-                <a:cs typeface="Arial"/>
-              </a:rPr>
-              <a:t>than to </a:t>
-            </a:r>
-            <a:r>
-              <a:rPr lang="en-US" dirty="0">
-                <a:solidFill>
-                  <a:srgbClr val="000000"/>
-                </a:solidFill>
-                <a:cs typeface="Arial"/>
-              </a:rPr>
-              <a:t>deploy (certification)</a:t>
+              <a:t>Solutions are much easier to write than to deploy (certification)</a:t>
             </a:r>
           </a:p>
           <a:p>
@@ -5182,7 +5586,7 @@
                 <a:spcPct val="0"/>
               </a:spcAft>
             </a:pPr>
-            <a:endParaRPr lang="en-US" dirty="0">
+            <a:endParaRPr lang="en-US">
               <a:solidFill>
                 <a:srgbClr val="595959"/>
               </a:solidFill>
@@ -5207,12 +5611,6 @@
               </a:rPr>
               <a:t>Solutions inspired higher trust in Generative AI</a:t>
             </a:r>
-            <a:endParaRPr lang="en-US" b="1" dirty="0">
-              <a:solidFill>
-                <a:srgbClr val="000000"/>
-              </a:solidFill>
-              <a:cs typeface="Arial"/>
-            </a:endParaRPr>
           </a:p>
           <a:p>
             <a:pPr>
@@ -5224,29 +5622,14 @@
               </a:spcAft>
             </a:pPr>
             <a:r>
-              <a:rPr lang="en-US" dirty="0">
+              <a:rPr lang="en-US">
                 <a:solidFill>
                   <a:srgbClr val="000000"/>
                 </a:solidFill>
                 <a:cs typeface="Arial"/>
               </a:rPr>
-              <a:t>Clinicians confident enough to agree on further deployment of Agentic </a:t>
-            </a:r>
-            <a:r>
-              <a:rPr lang="en-US">
-                <a:solidFill>
-                  <a:srgbClr val="000000"/>
-                </a:solidFill>
-                <a:cs typeface="Arial"/>
-              </a:rPr>
-              <a:t>AI in research</a:t>
-            </a:r>
-            <a:endParaRPr lang="en-US" dirty="0">
-              <a:solidFill>
-                <a:srgbClr val="000000"/>
-              </a:solidFill>
-              <a:cs typeface="Arial"/>
-            </a:endParaRPr>
+              <a:t>Clinicians confident enough to agree on further deployment of Agentic AI in research</a:t>
+            </a:r>
           </a:p>
           <a:p>
             <a:pPr>
@@ -5257,7 +5640,7 @@
                 <a:spcPct val="0"/>
               </a:spcAft>
             </a:pPr>
-            <a:endParaRPr lang="en-US" dirty="0">
+            <a:endParaRPr lang="en-US">
               <a:solidFill>
                 <a:srgbClr val="595959"/>
               </a:solidFill>
@@ -5293,7 +5676,7 @@
               </a:spcAft>
             </a:pPr>
             <a:r>
-              <a:rPr lang="en-US" dirty="0">
+              <a:rPr lang="en-US">
                 <a:ea typeface="+mn-lt"/>
                 <a:cs typeface="+mn-lt"/>
               </a:rPr>
@@ -5315,9 +5698,6 @@
               </a:rPr>
               <a:t>Dario Amodei</a:t>
             </a:r>
-            <a:endParaRPr lang="en-US" dirty="0">
-              <a:cs typeface="Arial"/>
-            </a:endParaRPr>
           </a:p>
         </p:txBody>
       </p:sp>
@@ -5458,6 +5838,424 @@
 </file>
 
 <file path=ppt/slides/slide11.xml><?xml version="1.0" encoding="utf-8"?>
+<p:sld xmlns:a="http://schemas.openxmlformats.org/drawingml/2006/main" xmlns:r="http://schemas.openxmlformats.org/officeDocument/2006/relationships" xmlns:p="http://schemas.openxmlformats.org/presentationml/2006/main">
+  <p:cSld>
+    <p:spTree>
+      <p:nvGrpSpPr>
+        <p:cNvPr id="1" name=""/>
+        <p:cNvGrpSpPr/>
+        <p:nvPr/>
+      </p:nvGrpSpPr>
+      <p:grpSpPr>
+        <a:xfrm>
+          <a:off x="0" y="0"/>
+          <a:ext cx="0" cy="0"/>
+          <a:chOff x="0" y="0"/>
+          <a:chExt cx="0" cy="0"/>
+        </a:xfrm>
+      </p:grpSpPr>
+      <p:sp>
+        <p:nvSpPr>
+          <p:cNvPr id="2" name="Content Placeholder 1">
+            <a:extLst>
+              <a:ext uri="{FF2B5EF4-FFF2-40B4-BE49-F238E27FC236}">
+                <a16:creationId xmlns:a16="http://schemas.microsoft.com/office/drawing/2014/main" id="{06619FF3-9E25-4987-5B7B-1974A8ADADB8}"/>
+              </a:ext>
+            </a:extLst>
+          </p:cNvPr>
+          <p:cNvSpPr>
+            <a:spLocks noGrp="1"/>
+          </p:cNvSpPr>
+          <p:nvPr>
+            <p:ph idx="1"/>
+          </p:nvPr>
+        </p:nvSpPr>
+        <p:spPr>
+          <a:xfrm>
+            <a:off x="1487488" y="1604797"/>
+            <a:ext cx="10416270" cy="4389320"/>
+          </a:xfrm>
+        </p:spPr>
+        <p:txBody>
+          <a:bodyPr lIns="91440" tIns="45720" rIns="91440" bIns="45720" anchor="t"/>
+          <a:lstStyle>
+            <a:defPPr>
+              <a:defRPr lang="en-GB"/>
+            </a:defPPr>
+            <a:lvl1pPr algn="l" rtl="0" fontAlgn="base">
+              <a:spcBef>
+                <a:spcPct val="0"/>
+              </a:spcBef>
+              <a:spcAft>
+                <a:spcPct val="0"/>
+              </a:spcAft>
+              <a:defRPr kern="1200">
+                <a:solidFill>
+                  <a:schemeClr val="tx1"/>
+                </a:solidFill>
+                <a:latin typeface="Arial" charset="0"/>
+                <a:ea typeface="ＭＳ Ｐゴシック" pitchFamily="-107" charset="-128"/>
+                <a:cs typeface="+mn-cs"/>
+              </a:defRPr>
+            </a:lvl1pPr>
+            <a:lvl2pPr marL="609585" algn="l" rtl="0" fontAlgn="base">
+              <a:spcBef>
+                <a:spcPct val="0"/>
+              </a:spcBef>
+              <a:spcAft>
+                <a:spcPct val="0"/>
+              </a:spcAft>
+              <a:defRPr kern="1200">
+                <a:solidFill>
+                  <a:schemeClr val="tx1"/>
+                </a:solidFill>
+                <a:latin typeface="Arial" charset="0"/>
+                <a:ea typeface="ＭＳ Ｐゴシック" pitchFamily="-107" charset="-128"/>
+                <a:cs typeface="+mn-cs"/>
+              </a:defRPr>
+            </a:lvl2pPr>
+            <a:lvl3pPr marL="1219170" algn="l" rtl="0" fontAlgn="base">
+              <a:spcBef>
+                <a:spcPct val="0"/>
+              </a:spcBef>
+              <a:spcAft>
+                <a:spcPct val="0"/>
+              </a:spcAft>
+              <a:defRPr kern="1200">
+                <a:solidFill>
+                  <a:schemeClr val="tx1"/>
+                </a:solidFill>
+                <a:latin typeface="Arial" charset="0"/>
+                <a:ea typeface="ＭＳ Ｐゴシック" pitchFamily="-107" charset="-128"/>
+                <a:cs typeface="+mn-cs"/>
+              </a:defRPr>
+            </a:lvl3pPr>
+            <a:lvl4pPr marL="1828754" algn="l" rtl="0" fontAlgn="base">
+              <a:spcBef>
+                <a:spcPct val="0"/>
+              </a:spcBef>
+              <a:spcAft>
+                <a:spcPct val="0"/>
+              </a:spcAft>
+              <a:defRPr kern="1200">
+                <a:solidFill>
+                  <a:schemeClr val="tx1"/>
+                </a:solidFill>
+                <a:latin typeface="Arial" charset="0"/>
+                <a:ea typeface="ＭＳ Ｐゴシック" pitchFamily="-107" charset="-128"/>
+                <a:cs typeface="+mn-cs"/>
+              </a:defRPr>
+            </a:lvl4pPr>
+            <a:lvl5pPr marL="2438339" algn="l" rtl="0" fontAlgn="base">
+              <a:spcBef>
+                <a:spcPct val="0"/>
+              </a:spcBef>
+              <a:spcAft>
+                <a:spcPct val="0"/>
+              </a:spcAft>
+              <a:defRPr kern="1200">
+                <a:solidFill>
+                  <a:schemeClr val="tx1"/>
+                </a:solidFill>
+                <a:latin typeface="Arial" charset="0"/>
+                <a:ea typeface="ＭＳ Ｐゴシック" pitchFamily="-107" charset="-128"/>
+                <a:cs typeface="+mn-cs"/>
+              </a:defRPr>
+            </a:lvl5pPr>
+            <a:lvl6pPr marL="3047924" algn="l" defTabSz="1219170" rtl="0" eaLnBrk="1" latinLnBrk="0" hangingPunct="1">
+              <a:defRPr kern="1200">
+                <a:solidFill>
+                  <a:schemeClr val="tx1"/>
+                </a:solidFill>
+                <a:latin typeface="Arial" charset="0"/>
+                <a:ea typeface="ＭＳ Ｐゴシック" pitchFamily="-107" charset="-128"/>
+                <a:cs typeface="+mn-cs"/>
+              </a:defRPr>
+            </a:lvl6pPr>
+            <a:lvl7pPr marL="3657509" algn="l" defTabSz="1219170" rtl="0" eaLnBrk="1" latinLnBrk="0" hangingPunct="1">
+              <a:defRPr kern="1200">
+                <a:solidFill>
+                  <a:schemeClr val="tx1"/>
+                </a:solidFill>
+                <a:latin typeface="Arial" charset="0"/>
+                <a:ea typeface="ＭＳ Ｐゴシック" pitchFamily="-107" charset="-128"/>
+                <a:cs typeface="+mn-cs"/>
+              </a:defRPr>
+            </a:lvl7pPr>
+            <a:lvl8pPr marL="4267093" algn="l" defTabSz="1219170" rtl="0" eaLnBrk="1" latinLnBrk="0" hangingPunct="1">
+              <a:defRPr kern="1200">
+                <a:solidFill>
+                  <a:schemeClr val="tx1"/>
+                </a:solidFill>
+                <a:latin typeface="Arial" charset="0"/>
+                <a:ea typeface="ＭＳ Ｐゴシック" pitchFamily="-107" charset="-128"/>
+                <a:cs typeface="+mn-cs"/>
+              </a:defRPr>
+            </a:lvl8pPr>
+            <a:lvl9pPr marL="4876678" algn="l" defTabSz="1219170" rtl="0" eaLnBrk="1" latinLnBrk="0" hangingPunct="1">
+              <a:defRPr kern="1200">
+                <a:solidFill>
+                  <a:schemeClr val="tx1"/>
+                </a:solidFill>
+                <a:latin typeface="Arial" charset="0"/>
+                <a:ea typeface="ＭＳ Ｐゴシック" pitchFamily="-107" charset="-128"/>
+                <a:cs typeface="+mn-cs"/>
+              </a:defRPr>
+            </a:lvl9pPr>
+          </a:lstStyle>
+          <a:p>
+            <a:r>
+              <a:rPr lang="en-GB"/>
+              <a:t>Hackathons build skills</a:t>
+            </a:r>
+          </a:p>
+          <a:p>
+            <a:r>
+              <a:rPr lang="en-GB"/>
+              <a:t>CSG University of Practice</a:t>
+            </a:r>
+          </a:p>
+          <a:p>
+            <a:r>
+              <a:rPr lang="en-GB"/>
+              <a:t>AI upskilling, rapid fast</a:t>
+            </a:r>
+          </a:p>
+          <a:p>
+            <a:pPr marL="456565" indent="-456565"/>
+            <a:r>
+              <a:rPr lang="en-GB">
+                <a:latin typeface="Arial"/>
+                <a:ea typeface="ＭＳ Ｐゴシック"/>
+                <a:cs typeface="Arial"/>
+              </a:rPr>
+              <a:t>Inline with </a:t>
+            </a:r>
+            <a:r>
+              <a:rPr lang="en-GB" err="1">
+                <a:latin typeface="Arial"/>
+                <a:ea typeface="ＭＳ Ｐゴシック"/>
+                <a:cs typeface="Arial"/>
+              </a:rPr>
+              <a:t>Worldskills</a:t>
+            </a:r>
+            <a:r>
+              <a:rPr lang="en-GB">
+                <a:latin typeface="Arial"/>
+                <a:ea typeface="ＭＳ Ｐゴシック"/>
+                <a:cs typeface="Arial"/>
+              </a:rPr>
+              <a:t> Pressure Test approach. </a:t>
+            </a:r>
+          </a:p>
+          <a:p>
+            <a:pPr marL="456565" indent="-456565"/>
+            <a:r>
+              <a:rPr lang="en-GB">
+                <a:latin typeface="Arial"/>
+                <a:ea typeface="ＭＳ Ｐゴシック"/>
+                <a:cs typeface="Arial"/>
+              </a:rPr>
+              <a:t>Solutions been tested, Industry standards leading to Research, Data</a:t>
+            </a:r>
+          </a:p>
+          <a:p>
+            <a:endParaRPr lang="en-GB"/>
+          </a:p>
+          <a:p>
+            <a:r>
+              <a:rPr lang="en-GB"/>
+              <a:t>Join us in quest to keep up with pace of AI change</a:t>
+            </a:r>
+          </a:p>
+          <a:p>
+            <a:r>
+              <a:rPr lang="en-GB"/>
+              <a:t>So far Clinical, Electrical, next …..</a:t>
+            </a:r>
+          </a:p>
+        </p:txBody>
+      </p:sp>
+      <p:sp>
+        <p:nvSpPr>
+          <p:cNvPr id="3" name="Title 2">
+            <a:extLst>
+              <a:ext uri="{FF2B5EF4-FFF2-40B4-BE49-F238E27FC236}">
+                <a16:creationId xmlns:a16="http://schemas.microsoft.com/office/drawing/2014/main" id="{B53075D6-9E27-07EE-AC56-8566C1C8AECA}"/>
+              </a:ext>
+            </a:extLst>
+          </p:cNvPr>
+          <p:cNvSpPr>
+            <a:spLocks noGrp="1"/>
+          </p:cNvSpPr>
+          <p:nvPr>
+            <p:ph type="title"/>
+          </p:nvPr>
+        </p:nvSpPr>
+        <p:spPr>
+          <a:xfrm>
+            <a:off x="1438515" y="306273"/>
+            <a:ext cx="10510613" cy="1115219"/>
+          </a:xfrm>
+        </p:spPr>
+        <p:txBody>
+          <a:bodyPr lIns="91440" tIns="45720" rIns="91440" bIns="45720" anchor="t"/>
+          <a:lstStyle>
+            <a:defPPr>
+              <a:defRPr lang="en-GB"/>
+            </a:defPPr>
+            <a:lvl1pPr algn="l" rtl="0" fontAlgn="base">
+              <a:spcBef>
+                <a:spcPct val="0"/>
+              </a:spcBef>
+              <a:spcAft>
+                <a:spcPct val="0"/>
+              </a:spcAft>
+              <a:defRPr kern="1200">
+                <a:solidFill>
+                  <a:schemeClr val="tx1"/>
+                </a:solidFill>
+                <a:latin typeface="Arial" charset="0"/>
+                <a:ea typeface="ＭＳ Ｐゴシック" pitchFamily="-107" charset="-128"/>
+                <a:cs typeface="+mn-cs"/>
+              </a:defRPr>
+            </a:lvl1pPr>
+            <a:lvl2pPr marL="609585" algn="l" rtl="0" fontAlgn="base">
+              <a:spcBef>
+                <a:spcPct val="0"/>
+              </a:spcBef>
+              <a:spcAft>
+                <a:spcPct val="0"/>
+              </a:spcAft>
+              <a:defRPr kern="1200">
+                <a:solidFill>
+                  <a:schemeClr val="tx1"/>
+                </a:solidFill>
+                <a:latin typeface="Arial" charset="0"/>
+                <a:ea typeface="ＭＳ Ｐゴシック" pitchFamily="-107" charset="-128"/>
+                <a:cs typeface="+mn-cs"/>
+              </a:defRPr>
+            </a:lvl2pPr>
+            <a:lvl3pPr marL="1219170" algn="l" rtl="0" fontAlgn="base">
+              <a:spcBef>
+                <a:spcPct val="0"/>
+              </a:spcBef>
+              <a:spcAft>
+                <a:spcPct val="0"/>
+              </a:spcAft>
+              <a:defRPr kern="1200">
+                <a:solidFill>
+                  <a:schemeClr val="tx1"/>
+                </a:solidFill>
+                <a:latin typeface="Arial" charset="0"/>
+                <a:ea typeface="ＭＳ Ｐゴシック" pitchFamily="-107" charset="-128"/>
+                <a:cs typeface="+mn-cs"/>
+              </a:defRPr>
+            </a:lvl3pPr>
+            <a:lvl4pPr marL="1828754" algn="l" rtl="0" fontAlgn="base">
+              <a:spcBef>
+                <a:spcPct val="0"/>
+              </a:spcBef>
+              <a:spcAft>
+                <a:spcPct val="0"/>
+              </a:spcAft>
+              <a:defRPr kern="1200">
+                <a:solidFill>
+                  <a:schemeClr val="tx1"/>
+                </a:solidFill>
+                <a:latin typeface="Arial" charset="0"/>
+                <a:ea typeface="ＭＳ Ｐゴシック" pitchFamily="-107" charset="-128"/>
+                <a:cs typeface="+mn-cs"/>
+              </a:defRPr>
+            </a:lvl4pPr>
+            <a:lvl5pPr marL="2438339" algn="l" rtl="0" fontAlgn="base">
+              <a:spcBef>
+                <a:spcPct val="0"/>
+              </a:spcBef>
+              <a:spcAft>
+                <a:spcPct val="0"/>
+              </a:spcAft>
+              <a:defRPr kern="1200">
+                <a:solidFill>
+                  <a:schemeClr val="tx1"/>
+                </a:solidFill>
+                <a:latin typeface="Arial" charset="0"/>
+                <a:ea typeface="ＭＳ Ｐゴシック" pitchFamily="-107" charset="-128"/>
+                <a:cs typeface="+mn-cs"/>
+              </a:defRPr>
+            </a:lvl5pPr>
+            <a:lvl6pPr marL="3047924" algn="l" defTabSz="1219170" rtl="0" eaLnBrk="1" latinLnBrk="0" hangingPunct="1">
+              <a:defRPr kern="1200">
+                <a:solidFill>
+                  <a:schemeClr val="tx1"/>
+                </a:solidFill>
+                <a:latin typeface="Arial" charset="0"/>
+                <a:ea typeface="ＭＳ Ｐゴシック" pitchFamily="-107" charset="-128"/>
+                <a:cs typeface="+mn-cs"/>
+              </a:defRPr>
+            </a:lvl6pPr>
+            <a:lvl7pPr marL="3657509" algn="l" defTabSz="1219170" rtl="0" eaLnBrk="1" latinLnBrk="0" hangingPunct="1">
+              <a:defRPr kern="1200">
+                <a:solidFill>
+                  <a:schemeClr val="tx1"/>
+                </a:solidFill>
+                <a:latin typeface="Arial" charset="0"/>
+                <a:ea typeface="ＭＳ Ｐゴシック" pitchFamily="-107" charset="-128"/>
+                <a:cs typeface="+mn-cs"/>
+              </a:defRPr>
+            </a:lvl7pPr>
+            <a:lvl8pPr marL="4267093" algn="l" defTabSz="1219170" rtl="0" eaLnBrk="1" latinLnBrk="0" hangingPunct="1">
+              <a:defRPr kern="1200">
+                <a:solidFill>
+                  <a:schemeClr val="tx1"/>
+                </a:solidFill>
+                <a:latin typeface="Arial" charset="0"/>
+                <a:ea typeface="ＭＳ Ｐゴシック" pitchFamily="-107" charset="-128"/>
+                <a:cs typeface="+mn-cs"/>
+              </a:defRPr>
+            </a:lvl8pPr>
+            <a:lvl9pPr marL="4876678" algn="l" defTabSz="1219170" rtl="0" eaLnBrk="1" latinLnBrk="0" hangingPunct="1">
+              <a:defRPr kern="1200">
+                <a:solidFill>
+                  <a:schemeClr val="tx1"/>
+                </a:solidFill>
+                <a:latin typeface="Arial" charset="0"/>
+                <a:ea typeface="ＭＳ Ｐゴシック" pitchFamily="-107" charset="-128"/>
+                <a:cs typeface="+mn-cs"/>
+              </a:defRPr>
+            </a:lvl9pPr>
+          </a:lstStyle>
+          <a:p>
+            <a:r>
+              <a:rPr lang="en-US" sz="3600">
+                <a:latin typeface="Arial"/>
+                <a:ea typeface="ＭＳ Ｐゴシック"/>
+                <a:cs typeface="Arial"/>
+              </a:rPr>
+              <a:t>Scaling Hackathons Across Disciplines and Domains for Research</a:t>
+            </a:r>
+            <a:endParaRPr lang="en-GB" sz="3600">
+              <a:latin typeface="Arial"/>
+              <a:ea typeface="ＭＳ Ｐゴシック"/>
+              <a:cs typeface="Arial"/>
+            </a:endParaRPr>
+          </a:p>
+        </p:txBody>
+      </p:sp>
+    </p:spTree>
+    <p:extLst>
+      <p:ext uri="{BB962C8B-B14F-4D97-AF65-F5344CB8AC3E}">
+        <p14:creationId xmlns:p14="http://schemas.microsoft.com/office/powerpoint/2010/main" val="3907096797"/>
+      </p:ext>
+    </p:extLst>
+  </p:cSld>
+  <p:clrMapOvr>
+    <a:masterClrMapping/>
+  </p:clrMapOvr>
+</p:sld>
+</file>
+
+<file path=ppt/slides/slide12.xml><?xml version="1.0" encoding="utf-8"?>
 <p:sld xmlns:a="http://schemas.openxmlformats.org/drawingml/2006/main" xmlns:r="http://schemas.openxmlformats.org/officeDocument/2006/relationships" xmlns:p="http://schemas.openxmlformats.org/presentationml/2006/main">
   <p:cSld>
     <p:bg>
@@ -5757,7 +6555,7 @@
             <a:pPr marL="0" indent="0" algn="ctr">
               <a:buNone/>
             </a:pPr>
-            <a:endParaRPr lang="en-US" sz="1800" b="1" dirty="0">
+            <a:endParaRPr lang="en-US" sz="1800" b="1">
               <a:solidFill>
                 <a:srgbClr val="B5A9A1"/>
               </a:solidFill>
@@ -5794,7 +6592,7 @@
           <a:lstStyle/>
           <a:p>
             <a:r>
-              <a:rPr lang="en-US" b="1" dirty="0" err="1">
+              <a:rPr lang="en-US" b="1" err="1">
                 <a:solidFill>
                   <a:srgbClr val="000000"/>
                 </a:solidFill>
@@ -5804,7 +6602,7 @@
               <a:t>ElectroAI</a:t>
             </a:r>
             <a:r>
-              <a:rPr lang="en-US" b="1" dirty="0">
+              <a:rPr lang="en-US" b="1">
                 <a:solidFill>
                   <a:srgbClr val="000000"/>
                 </a:solidFill>
@@ -5813,7 +6611,7 @@
               </a:rPr>
               <a:t> Hackathon</a:t>
             </a:r>
-            <a:endParaRPr lang="en-US" dirty="0">
+            <a:endParaRPr lang="en-US">
               <a:solidFill>
                 <a:srgbClr val="595959"/>
               </a:solidFill>
@@ -5851,7 +6649,7 @@
                 <a:spcPct val="0"/>
               </a:spcAft>
             </a:pPr>
-            <a:endParaRPr lang="en-US" dirty="0">
+            <a:endParaRPr lang="en-US">
               <a:solidFill>
                 <a:srgbClr val="595959"/>
               </a:solidFill>
@@ -5902,7 +6700,67 @@
               </a:rPr>
               <a:t>City St George's, University of London 30.06-01.07.2026</a:t>
             </a:r>
-            <a:endParaRPr lang="en-US" dirty="0">
+          </a:p>
+          <a:p>
+            <a:pPr>
+              <a:spcBef>
+                <a:spcPct val="0"/>
+              </a:spcBef>
+              <a:spcAft>
+                <a:spcPct val="0"/>
+              </a:spcAft>
+            </a:pPr>
+            <a:endParaRPr lang="en-US">
+              <a:solidFill>
+                <a:srgbClr val="B5A9A1"/>
+              </a:solidFill>
+              <a:cs typeface="Arial"/>
+            </a:endParaRPr>
+          </a:p>
+          <a:p>
+            <a:r>
+              <a:rPr lang="en-US" b="1"/>
+              <a:t>Learning at City St George’s Conference 2026 </a:t>
+            </a:r>
+            <a:r>
+              <a:rPr lang="en-US" b="1">
+                <a:latin typeface="Aptos"/>
+              </a:rPr>
+              <a:t>– Snap Circuits Workshop</a:t>
+            </a:r>
+            <a:endParaRPr lang="en-US">
+              <a:latin typeface="Aptos"/>
+            </a:endParaRPr>
+          </a:p>
+          <a:p>
+            <a:pPr>
+              <a:spcBef>
+                <a:spcPct val="0"/>
+              </a:spcBef>
+              <a:spcAft>
+                <a:spcPct val="0"/>
+              </a:spcAft>
+            </a:pPr>
+            <a:r>
+              <a:rPr lang="en-US">
+                <a:solidFill>
+                  <a:srgbClr val="595959"/>
+                </a:solidFill>
+                <a:cs typeface="Arial"/>
+              </a:rPr>
+              <a:t>City St George's, University of London 30.06.2026</a:t>
+            </a:r>
+          </a:p>
+          <a:p>
+            <a:pPr>
+              <a:spcBef>
+                <a:spcPct val="0"/>
+              </a:spcBef>
+              <a:spcAft>
+                <a:spcPct val="0"/>
+              </a:spcAft>
+            </a:pPr>
+            <a:endParaRPr lang="en-US">
               <a:solidFill>
                 <a:srgbClr val="595959"/>
               </a:solidFill>
@@ -5918,27 +6776,15 @@
                 <a:spcPct val="0"/>
               </a:spcAft>
             </a:pPr>
-            <a:endParaRPr lang="en-US" dirty="0">
-              <a:solidFill>
-                <a:srgbClr val="B5A9A1"/>
-              </a:solidFill>
-              <a:cs typeface="Arial"/>
-            </a:endParaRPr>
-          </a:p>
-          <a:p>
-            <a:r>
-              <a:rPr lang="en-US" b="1"/>
-              <a:t>Learning at City St George’s Conference 2026 </a:t>
-            </a:r>
             <a:r>
               <a:rPr lang="en-US" b="1">
-                <a:latin typeface="Aptos"/>
-              </a:rPr>
-              <a:t>– Snap Circuits Workshop</a:t>
-            </a:r>
-            <a:endParaRPr lang="en-US">
-              <a:latin typeface="Aptos"/>
-            </a:endParaRPr>
+                <a:solidFill>
+                  <a:srgbClr val="595959"/>
+                </a:solidFill>
+                <a:cs typeface="Arial"/>
+              </a:rPr>
+              <a:t>Slides, contacts</a:t>
+            </a:r>
           </a:p>
           <a:p>
             <a:pPr>
@@ -5954,9 +6800,10 @@
                 <a:solidFill>
                   <a:srgbClr val="595959"/>
                 </a:solidFill>
+                <a:latin typeface="Aptos"/>
                 <a:cs typeface="Arial"/>
               </a:rPr>
-              <a:t>City St George's, University of London 30.06.2026</a:t>
+              <a:t>Please scan QR code or visit</a:t>
             </a:r>
           </a:p>
           <a:p>
@@ -5968,63 +6815,8 @@
                 <a:spcPct val="0"/>
               </a:spcAft>
             </a:pPr>
-            <a:endParaRPr lang="en-US" dirty="0">
-              <a:solidFill>
-                <a:srgbClr val="595959"/>
-              </a:solidFill>
-              <a:cs typeface="Arial"/>
-            </a:endParaRPr>
-          </a:p>
-          <a:p>
-            <a:pPr>
-              <a:spcBef>
-                <a:spcPct val="0"/>
-              </a:spcBef>
-              <a:spcAft>
-                <a:spcPct val="0"/>
-              </a:spcAft>
-            </a:pPr>
-            <a:r>
-              <a:rPr lang="en-US" b="1">
-                <a:solidFill>
-                  <a:srgbClr val="595959"/>
-                </a:solidFill>
-                <a:cs typeface="Arial"/>
-              </a:rPr>
-              <a:t>Slides, contacts</a:t>
-            </a:r>
-          </a:p>
-          <a:p>
-            <a:pPr>
-              <a:spcBef>
-                <a:spcPct val="0"/>
-              </a:spcBef>
-              <a:spcAft>
-                <a:spcPct val="0"/>
-              </a:spcAft>
-            </a:pPr>
             <a:r>
               <a:rPr lang="en-US">
-                <a:solidFill>
-                  <a:srgbClr val="595959"/>
-                </a:solidFill>
-                <a:latin typeface="Aptos"/>
-                <a:cs typeface="Arial"/>
-              </a:rPr>
-              <a:t>Please scan QR code or visit</a:t>
-            </a:r>
-          </a:p>
-          <a:p>
-            <a:pPr>
-              <a:spcBef>
-                <a:spcPct val="0"/>
-              </a:spcBef>
-              <a:spcAft>
-                <a:spcPct val="0"/>
-              </a:spcAft>
-            </a:pPr>
-            <a:r>
-              <a:rPr lang="en-US" dirty="0">
                 <a:solidFill>
                   <a:srgbClr val="595959"/>
                 </a:solidFill>
@@ -6033,7 +6825,7 @@
               </a:rPr>
               <a:t>https://github.com/dsikar/csg-ai-research-day-2026</a:t>
             </a:r>
-            <a:endParaRPr lang="en-US" dirty="0"/>
+            <a:endParaRPr lang="en-US"/>
           </a:p>
         </p:txBody>
       </p:sp>
@@ -6420,7 +7212,7 @@
           <a:lstStyle/>
           <a:p>
             <a:pPr algn="ctr" rtl="0"/>
-            <a:endParaRPr lang="en-US" sz="2800" dirty="0">
+            <a:endParaRPr lang="en-US" sz="2800">
               <a:cs typeface="Arial"/>
             </a:endParaRPr>
           </a:p>
@@ -6738,7 +7530,7 @@
               </a:rPr>
               <a:t>​</a:t>
             </a:r>
-            <a:endParaRPr lang="en-US" sz="2700" b="1" dirty="0">
+            <a:endParaRPr lang="en-US" sz="2700" b="1">
               <a:solidFill>
                 <a:srgbClr val="1D1D1B"/>
               </a:solidFill>
@@ -6803,7 +7595,7 @@
             <a:pPr marL="0" indent="0" algn="ctr">
               <a:buNone/>
             </a:pPr>
-            <a:endParaRPr lang="en-US" sz="1800" b="1" dirty="0">
+            <a:endParaRPr lang="en-US" sz="1800" b="1">
               <a:solidFill>
                 <a:srgbClr val="B5A9A1"/>
               </a:solidFill>
@@ -6849,194 +7641,6 @@
                 <a:cs typeface="Arial"/>
               </a:rPr>
               <a:t>Paper</a:t>
-            </a:r>
-            <a:endParaRPr lang="en-US" dirty="0">
-              <a:solidFill>
-                <a:srgbClr val="B5A9A1"/>
-              </a:solidFill>
-              <a:cs typeface="Arial"/>
-            </a:endParaRPr>
-          </a:p>
-          <a:p>
-            <a:pPr>
-              <a:spcBef>
-                <a:spcPct val="0"/>
-              </a:spcBef>
-              <a:spcAft>
-                <a:spcPct val="0"/>
-              </a:spcAft>
-            </a:pPr>
-            <a:endParaRPr lang="en-US" dirty="0">
-              <a:solidFill>
-                <a:srgbClr val="B5A9A1"/>
-              </a:solidFill>
-              <a:cs typeface="Arial"/>
-            </a:endParaRPr>
-          </a:p>
-          <a:p>
-            <a:pPr>
-              <a:spcBef>
-                <a:spcPct val="0"/>
-              </a:spcBef>
-              <a:spcAft>
-                <a:spcPct val="0"/>
-              </a:spcAft>
-            </a:pPr>
-            <a:r>
-              <a:rPr lang="en-US" dirty="0" err="1">
-                <a:solidFill>
-                  <a:srgbClr val="595959"/>
-                </a:solidFill>
-                <a:cs typeface="Arial"/>
-              </a:rPr>
-              <a:t>ArXiv</a:t>
-            </a:r>
-            <a:r>
-              <a:rPr lang="en-US" dirty="0">
-                <a:solidFill>
-                  <a:srgbClr val="595959"/>
-                </a:solidFill>
-                <a:cs typeface="Arial"/>
-              </a:rPr>
-              <a:t> -  [Submitted on 12 Aug </a:t>
-            </a:r>
-            <a:r>
-              <a:rPr lang="en-US" b="1" dirty="0">
-                <a:solidFill>
-                  <a:srgbClr val="595959"/>
-                </a:solidFill>
-                <a:cs typeface="Arial"/>
-              </a:rPr>
-              <a:t>2024 </a:t>
-            </a:r>
-            <a:r>
-              <a:rPr lang="en-US" dirty="0">
-                <a:solidFill>
-                  <a:srgbClr val="595959"/>
-                </a:solidFill>
-                <a:cs typeface="Arial"/>
-              </a:rPr>
-              <a:t>(v1), last revised 1 Sep 2024]</a:t>
-            </a:r>
-            <a:endParaRPr lang="en-US" dirty="0">
-              <a:solidFill>
-                <a:srgbClr val="B5A9A1"/>
-              </a:solidFill>
-              <a:cs typeface="Arial"/>
-            </a:endParaRPr>
-          </a:p>
-          <a:p>
-            <a:pPr>
-              <a:spcBef>
-                <a:spcPct val="0"/>
-              </a:spcBef>
-              <a:spcAft>
-                <a:spcPct val="0"/>
-              </a:spcAft>
-            </a:pPr>
-            <a:r>
-              <a:rPr lang="en-US" dirty="0">
-                <a:solidFill>
-                  <a:srgbClr val="0097A7"/>
-                </a:solidFill>
-                <a:cs typeface="Arial"/>
-                <a:hlinkClick r:id="rId4"/>
-              </a:rPr>
-              <a:t>https://arxiv.org/abs/2408.06292</a:t>
-            </a:r>
-            <a:endParaRPr lang="en-US" dirty="0">
-              <a:solidFill>
-                <a:srgbClr val="B5A9A1"/>
-              </a:solidFill>
-              <a:cs typeface="Arial"/>
-            </a:endParaRPr>
-          </a:p>
-          <a:p>
-            <a:pPr>
-              <a:spcBef>
-                <a:spcPct val="0"/>
-              </a:spcBef>
-              <a:spcAft>
-                <a:spcPct val="0"/>
-              </a:spcAft>
-            </a:pPr>
-            <a:endParaRPr lang="en-US" dirty="0">
-              <a:solidFill>
-                <a:srgbClr val="B5A9A1"/>
-              </a:solidFill>
-              <a:cs typeface="Arial"/>
-            </a:endParaRPr>
-          </a:p>
-          <a:p>
-            <a:pPr>
-              <a:spcBef>
-                <a:spcPct val="0"/>
-              </a:spcBef>
-              <a:spcAft>
-                <a:spcPct val="0"/>
-              </a:spcAft>
-            </a:pPr>
-            <a:r>
-              <a:rPr lang="en-US" b="1" u="sng">
-                <a:solidFill>
-                  <a:srgbClr val="595959"/>
-                </a:solidFill>
-                <a:cs typeface="Arial"/>
-              </a:rPr>
-              <a:t>Company website</a:t>
-            </a:r>
-            <a:endParaRPr lang="en-US" dirty="0">
-              <a:solidFill>
-                <a:srgbClr val="B5A9A1"/>
-              </a:solidFill>
-              <a:cs typeface="Arial"/>
-            </a:endParaRPr>
-          </a:p>
-          <a:p>
-            <a:pPr>
-              <a:spcBef>
-                <a:spcPct val="0"/>
-              </a:spcBef>
-              <a:spcAft>
-                <a:spcPct val="0"/>
-              </a:spcAft>
-            </a:pPr>
-            <a:r>
-              <a:rPr lang="en-US" b="1" dirty="0" err="1">
-                <a:solidFill>
-                  <a:srgbClr val="595959"/>
-                </a:solidFill>
-                <a:cs typeface="Arial"/>
-              </a:rPr>
-              <a:t>SakanaAI</a:t>
-            </a:r>
-            <a:r>
-              <a:rPr lang="en-US" b="1" dirty="0">
-                <a:solidFill>
-                  <a:srgbClr val="595959"/>
-                </a:solidFill>
-                <a:cs typeface="Arial"/>
-              </a:rPr>
-              <a:t> </a:t>
-            </a:r>
-            <a:r>
-              <a:rPr lang="en-US" dirty="0">
-                <a:solidFill>
-                  <a:srgbClr val="595959"/>
-                </a:solidFill>
-                <a:cs typeface="Arial"/>
-              </a:rPr>
-              <a:t>- </a:t>
-            </a:r>
-            <a:r>
-              <a:rPr lang="en-US" dirty="0">
-                <a:solidFill>
-                  <a:srgbClr val="0097A7"/>
-                </a:solidFill>
-                <a:cs typeface="Arial"/>
-                <a:hlinkClick r:id="rId5"/>
-              </a:rPr>
-              <a:t>https://sakana.ai/</a:t>
             </a:r>
             <a:endParaRPr lang="en-US">
               <a:solidFill>
@@ -7054,7 +7658,7 @@
                 <a:spcPct val="0"/>
               </a:spcAft>
             </a:pPr>
-            <a:endParaRPr lang="en-US" dirty="0">
+            <a:endParaRPr lang="en-US">
               <a:solidFill>
                 <a:srgbClr val="B5A9A1"/>
               </a:solidFill>
@@ -7071,15 +7675,42 @@
               </a:spcAft>
             </a:pPr>
             <a:r>
-              <a:rPr lang="en-US" b="1" u="sng">
+              <a:rPr lang="en-US" err="1">
                 <a:solidFill>
                   <a:srgbClr val="595959"/>
                 </a:solidFill>
                 <a:cs typeface="Arial"/>
               </a:rPr>
-              <a:t>News</a:t>
-            </a:r>
-            <a:endParaRPr lang="en-US" dirty="0">
+              <a:t>ArXiv</a:t>
+            </a:r>
+            <a:r>
+              <a:rPr lang="en-US">
+                <a:solidFill>
+                  <a:srgbClr val="595959"/>
+                </a:solidFill>
+                <a:cs typeface="Arial"/>
+              </a:rPr>
+              <a:t> -  [Submitted on 12 Aug </a:t>
+            </a:r>
+            <a:r>
+              <a:rPr lang="en-US" b="1">
+                <a:solidFill>
+                  <a:srgbClr val="595959"/>
+                </a:solidFill>
+                <a:cs typeface="Arial"/>
+              </a:rPr>
+              <a:t>2024 </a:t>
+            </a:r>
+            <a:r>
+              <a:rPr lang="en-US">
+                <a:solidFill>
+                  <a:srgbClr val="595959"/>
+                </a:solidFill>
+                <a:cs typeface="Arial"/>
+              </a:rPr>
+              <a:t>(v1), last revised 1 Sep 2024]</a:t>
+            </a:r>
+            <a:endParaRPr lang="en-US">
               <a:solidFill>
                 <a:srgbClr val="B5A9A1"/>
               </a:solidFill>
@@ -7098,31 +7729,14 @@
             <a:r>
               <a:rPr lang="en-US">
                 <a:solidFill>
-                  <a:srgbClr val="595959"/>
+                  <a:srgbClr val="0097A7"/>
                 </a:solidFill>
                 <a:cs typeface="Arial"/>
-              </a:rPr>
-              <a:t>“Japan’s NVIDIA-backed </a:t>
-            </a:r>
-            <a:r>
-              <a:rPr lang="en-US" b="1">
-                <a:solidFill>
-                  <a:srgbClr val="595959"/>
-                </a:solidFill>
-                <a:cs typeface="Arial"/>
-              </a:rPr>
-              <a:t>Sakana AI raises $214m</a:t>
-            </a:r>
-            <a:r>
-              <a:rPr lang="en-US">
-                <a:solidFill>
-                  <a:srgbClr val="595959"/>
-                </a:solidFill>
-                <a:cs typeface="Arial"/>
-              </a:rPr>
-              <a:t>”</a:t>
-            </a:r>
-            <a:endParaRPr lang="en-US" dirty="0">
+                <a:hlinkClick r:id="rId4"/>
+              </a:rPr>
+              <a:t>https://arxiv.org/abs/2408.06292</a:t>
+            </a:r>
+            <a:endParaRPr lang="en-US">
               <a:solidFill>
                 <a:srgbClr val="B5A9A1"/>
               </a:solidFill>
@@ -7138,8 +7752,186 @@
                 <a:spcPct val="0"/>
               </a:spcAft>
             </a:pPr>
-            <a:r>
-              <a:rPr lang="en-US" dirty="0">
+            <a:endParaRPr lang="en-US">
+              <a:solidFill>
+                <a:srgbClr val="B5A9A1"/>
+              </a:solidFill>
+              <a:cs typeface="Arial"/>
+            </a:endParaRPr>
+          </a:p>
+          <a:p>
+            <a:pPr>
+              <a:spcBef>
+                <a:spcPct val="0"/>
+              </a:spcBef>
+              <a:spcAft>
+                <a:spcPct val="0"/>
+              </a:spcAft>
+            </a:pPr>
+            <a:r>
+              <a:rPr lang="en-US" b="1" u="sng">
+                <a:solidFill>
+                  <a:srgbClr val="595959"/>
+                </a:solidFill>
+                <a:cs typeface="Arial"/>
+              </a:rPr>
+              <a:t>Company website</a:t>
+            </a:r>
+            <a:endParaRPr lang="en-US">
+              <a:solidFill>
+                <a:srgbClr val="B5A9A1"/>
+              </a:solidFill>
+              <a:cs typeface="Arial"/>
+            </a:endParaRPr>
+          </a:p>
+          <a:p>
+            <a:pPr>
+              <a:spcBef>
+                <a:spcPct val="0"/>
+              </a:spcBef>
+              <a:spcAft>
+                <a:spcPct val="0"/>
+              </a:spcAft>
+            </a:pPr>
+            <a:r>
+              <a:rPr lang="en-US" b="1" err="1">
+                <a:solidFill>
+                  <a:srgbClr val="595959"/>
+                </a:solidFill>
+                <a:cs typeface="Arial"/>
+              </a:rPr>
+              <a:t>SakanaAI</a:t>
+            </a:r>
+            <a:r>
+              <a:rPr lang="en-US" b="1">
+                <a:solidFill>
+                  <a:srgbClr val="595959"/>
+                </a:solidFill>
+                <a:cs typeface="Arial"/>
+              </a:rPr>
+              <a:t> </a:t>
+            </a:r>
+            <a:r>
+              <a:rPr lang="en-US">
+                <a:solidFill>
+                  <a:srgbClr val="595959"/>
+                </a:solidFill>
+                <a:cs typeface="Arial"/>
+              </a:rPr>
+              <a:t>- </a:t>
+            </a:r>
+            <a:r>
+              <a:rPr lang="en-US">
+                <a:solidFill>
+                  <a:srgbClr val="0097A7"/>
+                </a:solidFill>
+                <a:cs typeface="Arial"/>
+                <a:hlinkClick r:id="rId5"/>
+              </a:rPr>
+              <a:t>https://sakana.ai/</a:t>
+            </a:r>
+            <a:endParaRPr lang="en-US">
+              <a:solidFill>
+                <a:srgbClr val="B5A9A1"/>
+              </a:solidFill>
+              <a:cs typeface="Arial"/>
+            </a:endParaRPr>
+          </a:p>
+          <a:p>
+            <a:pPr>
+              <a:spcBef>
+                <a:spcPct val="0"/>
+              </a:spcBef>
+              <a:spcAft>
+                <a:spcPct val="0"/>
+              </a:spcAft>
+            </a:pPr>
+            <a:endParaRPr lang="en-US">
+              <a:solidFill>
+                <a:srgbClr val="B5A9A1"/>
+              </a:solidFill>
+              <a:cs typeface="Arial"/>
+            </a:endParaRPr>
+          </a:p>
+          <a:p>
+            <a:pPr>
+              <a:spcBef>
+                <a:spcPct val="0"/>
+              </a:spcBef>
+              <a:spcAft>
+                <a:spcPct val="0"/>
+              </a:spcAft>
+            </a:pPr>
+            <a:r>
+              <a:rPr lang="en-US" b="1" u="sng">
+                <a:solidFill>
+                  <a:srgbClr val="595959"/>
+                </a:solidFill>
+                <a:cs typeface="Arial"/>
+              </a:rPr>
+              <a:t>News</a:t>
+            </a:r>
+            <a:endParaRPr lang="en-US">
+              <a:solidFill>
+                <a:srgbClr val="B5A9A1"/>
+              </a:solidFill>
+              <a:cs typeface="Arial"/>
+            </a:endParaRPr>
+          </a:p>
+          <a:p>
+            <a:pPr>
+              <a:spcBef>
+                <a:spcPct val="0"/>
+              </a:spcBef>
+              <a:spcAft>
+                <a:spcPct val="0"/>
+              </a:spcAft>
+            </a:pPr>
+            <a:r>
+              <a:rPr lang="en-US">
+                <a:solidFill>
+                  <a:srgbClr val="595959"/>
+                </a:solidFill>
+                <a:cs typeface="Arial"/>
+              </a:rPr>
+              <a:t>“Japan’s NVIDIA-backed </a:t>
+            </a:r>
+            <a:r>
+              <a:rPr lang="en-US" b="1">
+                <a:solidFill>
+                  <a:srgbClr val="595959"/>
+                </a:solidFill>
+                <a:cs typeface="Arial"/>
+              </a:rPr>
+              <a:t>Sakana AI raises $214m</a:t>
+            </a:r>
+            <a:r>
+              <a:rPr lang="en-US">
+                <a:solidFill>
+                  <a:srgbClr val="595959"/>
+                </a:solidFill>
+                <a:cs typeface="Arial"/>
+              </a:rPr>
+              <a:t>”</a:t>
+            </a:r>
+            <a:endParaRPr lang="en-US">
+              <a:solidFill>
+                <a:srgbClr val="B5A9A1"/>
+              </a:solidFill>
+              <a:cs typeface="Arial"/>
+            </a:endParaRPr>
+          </a:p>
+          <a:p>
+            <a:pPr>
+              <a:spcBef>
+                <a:spcPct val="0"/>
+              </a:spcBef>
+              <a:spcAft>
+                <a:spcPct val="0"/>
+              </a:spcAft>
+            </a:pPr>
+            <a:r>
+              <a:rPr lang="en-US">
                 <a:solidFill>
                   <a:srgbClr val="595959"/>
                 </a:solidFill>
@@ -7478,7 +8270,7 @@
               </a:rPr>
               <a:t>​</a:t>
             </a:r>
-            <a:endParaRPr lang="en-US" sz="2700" b="1" dirty="0">
+            <a:endParaRPr lang="en-US" sz="2700" b="1">
               <a:solidFill>
                 <a:srgbClr val="1D1D1B"/>
               </a:solidFill>
@@ -7561,7 +8353,7 @@
               </a:spcAft>
             </a:pPr>
             <a:r>
-              <a:rPr lang="en-US" sz="1250" dirty="0">
+              <a:rPr lang="en-US" sz="1250">
                 <a:solidFill>
                   <a:srgbClr val="B5A9A1"/>
                 </a:solidFill>
@@ -7622,7 +8414,7 @@
                 <a:spcPct val="0"/>
               </a:spcAft>
             </a:pPr>
-            <a:endParaRPr lang="en-US" sz="1200" dirty="0">
+            <a:endParaRPr lang="en-US" sz="1200">
               <a:solidFill>
                 <a:srgbClr val="B5A9A1"/>
               </a:solidFill>
@@ -7740,7 +8532,7 @@
               <a:t>write code</a:t>
             </a:r>
             <a:r>
-              <a:rPr lang="en-US" sz="1200" dirty="0">
+              <a:rPr lang="en-US" sz="1200">
                 <a:solidFill>
                   <a:srgbClr val="0F1419"/>
                 </a:solidFill>
@@ -7748,10 +8540,10 @@
                 <a:ea typeface="Arial" pitchFamily="34" charset="-122"/>
                 <a:cs typeface="Arial"/>
               </a:rPr>
-              <a:t> </a:t>
-            </a:r>
-            <a:r>
-              <a:rPr lang="en-US" sz="1200">
+              <a:t> (</a:t>
+            </a:r>
+            <a:r>
+              <a:rPr lang="en-US" sz="1200" b="1">
                 <a:solidFill>
                   <a:srgbClr val="0F1419"/>
                 </a:solidFill>
@@ -7759,10 +8551,10 @@
                 <a:ea typeface="Arial" pitchFamily="34" charset="-122"/>
                 <a:cs typeface="Arial"/>
               </a:rPr>
-              <a:t>(</a:t>
-            </a:r>
-            <a:r>
-              <a:rPr lang="en-US" sz="1200" b="1">
+              <a:t>Aider</a:t>
+            </a:r>
+            <a:r>
+              <a:rPr lang="en-US" sz="1200">
                 <a:solidFill>
                   <a:srgbClr val="0F1419"/>
                 </a:solidFill>
@@ -7770,10 +8562,10 @@
                 <a:ea typeface="Arial" pitchFamily="34" charset="-122"/>
                 <a:cs typeface="Arial"/>
               </a:rPr>
-              <a:t>Aider</a:t>
-            </a:r>
-            <a:r>
-              <a:rPr lang="en-US" sz="1200">
+              <a:t>, same backbone as </a:t>
+            </a:r>
+            <a:r>
+              <a:rPr lang="en-US" sz="1200" b="1">
                 <a:solidFill>
                   <a:srgbClr val="0F1419"/>
                 </a:solidFill>
@@ -7781,10 +8573,10 @@
                 <a:ea typeface="Arial" pitchFamily="34" charset="-122"/>
                 <a:cs typeface="Arial"/>
               </a:rPr>
-              <a:t>, same backbone as </a:t>
-            </a:r>
-            <a:r>
-              <a:rPr lang="en-US" sz="1200" b="1">
+              <a:t>Coder</a:t>
+            </a:r>
+            <a:r>
+              <a:rPr lang="en-US" sz="1200">
                 <a:solidFill>
                   <a:srgbClr val="0F1419"/>
                 </a:solidFill>
@@ -7792,20 +8584,9 @@
                 <a:ea typeface="Arial" pitchFamily="34" charset="-122"/>
                 <a:cs typeface="Arial"/>
               </a:rPr>
-              <a:t>Coder</a:t>
-            </a:r>
-            <a:r>
-              <a:rPr lang="en-US" sz="1200">
-                <a:solidFill>
-                  <a:srgbClr val="0F1419"/>
-                </a:solidFill>
-                <a:latin typeface="Arial"/>
-                <a:ea typeface="Arial" pitchFamily="34" charset="-122"/>
-                <a:cs typeface="Arial"/>
-              </a:rPr>
               <a:t>), execute experiments (via Python), visualize results, and author full scientific papers, complete with peer review, all autonomously.</a:t>
             </a:r>
-            <a:endParaRPr lang="en-US" sz="1200" dirty="0">
+            <a:endParaRPr lang="en-US" sz="1200">
               <a:solidFill>
                 <a:srgbClr val="B5A9A1"/>
               </a:solidFill>
@@ -7823,7 +8604,7 @@
                 <a:spcPct val="0"/>
               </a:spcAft>
             </a:pPr>
-            <a:endParaRPr lang="en-US" sz="1200" dirty="0">
+            <a:endParaRPr lang="en-US" sz="1200">
               <a:solidFill>
                 <a:srgbClr val="B5A9A1"/>
               </a:solidFill>
@@ -7842,7 +8623,7 @@
               </a:spcAft>
             </a:pPr>
             <a:r>
-              <a:rPr lang="en-US" sz="1200" b="1" dirty="0">
+              <a:rPr lang="en-US" sz="1200" b="1">
                 <a:solidFill>
                   <a:srgbClr val="0F1419"/>
                 </a:solidFill>
@@ -7853,7 +8634,7 @@
               <a:t>Templates</a:t>
             </a:r>
             <a:r>
-              <a:rPr lang="en-US" sz="1200" dirty="0">
+              <a:rPr lang="en-US" sz="1200">
                 <a:solidFill>
                   <a:srgbClr val="0F1419"/>
                 </a:solidFill>
@@ -7864,7 +8645,7 @@
               <a:t>: </a:t>
             </a:r>
             <a:r>
-              <a:rPr lang="en-US" sz="1200" b="1" dirty="0">
+              <a:rPr lang="en-US" sz="1200" b="1">
                 <a:solidFill>
                   <a:srgbClr val="0F1419"/>
                 </a:solidFill>
@@ -7875,7 +8656,7 @@
               <a:t>Provides</a:t>
             </a:r>
             <a:r>
-              <a:rPr lang="en-US" sz="1200" dirty="0">
+              <a:rPr lang="en-US" sz="1200">
                 <a:solidFill>
                   <a:srgbClr val="0F1419"/>
                 </a:solidFill>
@@ -7886,7 +8667,7 @@
               <a:t> </a:t>
             </a:r>
             <a:r>
-              <a:rPr lang="en-US" sz="1200" b="1" dirty="0">
+              <a:rPr lang="en-US" sz="1200" b="1">
                 <a:solidFill>
                   <a:srgbClr val="0F1419"/>
                 </a:solidFill>
@@ -7897,7 +8678,7 @@
               <a:t>three</a:t>
             </a:r>
             <a:r>
-              <a:rPr lang="en-US" sz="1200" dirty="0">
+              <a:rPr lang="en-US" sz="1200">
                 <a:solidFill>
                   <a:srgbClr val="0F1419"/>
                 </a:solidFill>
@@ -7908,7 +8689,7 @@
               <a:t> foundational </a:t>
             </a:r>
             <a:r>
-              <a:rPr lang="en-US" sz="1200" b="1" dirty="0">
+              <a:rPr lang="en-US" sz="1200" b="1">
                 <a:solidFill>
                   <a:srgbClr val="0F1419"/>
                 </a:solidFill>
@@ -7919,7 +8700,7 @@
               <a:t>templates</a:t>
             </a:r>
             <a:r>
-              <a:rPr lang="en-US" sz="1200" dirty="0">
+              <a:rPr lang="en-US" sz="1200">
                 <a:solidFill>
                   <a:srgbClr val="0F1419"/>
                 </a:solidFill>
@@ -7930,7 +8711,7 @@
               <a:t> for research in different domains: </a:t>
             </a:r>
             <a:r>
-              <a:rPr lang="en-US" sz="1200" dirty="0" err="1">
+              <a:rPr lang="en-US" sz="1200" err="1">
                 <a:solidFill>
                   <a:srgbClr val="0F1419"/>
                 </a:solidFill>
@@ -7941,7 +8722,7 @@
               <a:t>NanoGPT</a:t>
             </a:r>
             <a:r>
-              <a:rPr lang="en-US" sz="1200" dirty="0">
+              <a:rPr lang="en-US" sz="1200">
                 <a:solidFill>
                   <a:srgbClr val="0F1419"/>
                 </a:solidFill>
@@ -7951,7 +8732,7 @@
               </a:rPr>
               <a:t> for transformer-based tasks, 2D Diffusion for generative model performance, and Grokking for studying generalization in neural networks.</a:t>
             </a:r>
-            <a:endParaRPr lang="en-US" sz="1200" dirty="0">
+            <a:endParaRPr lang="en-US" sz="1200">
               <a:solidFill>
                 <a:srgbClr val="B5A9A1"/>
               </a:solidFill>
@@ -7969,7 +8750,7 @@
                 <a:spcPct val="0"/>
               </a:spcAft>
             </a:pPr>
-            <a:endParaRPr lang="en-US" sz="1200" dirty="0">
+            <a:endParaRPr lang="en-US" sz="1200">
               <a:solidFill>
                 <a:srgbClr val="B5A9A1"/>
               </a:solidFill>
@@ -7988,7 +8769,7 @@
               </a:spcAft>
             </a:pPr>
             <a:r>
-              <a:rPr lang="en-US" sz="1200" b="1" dirty="0">
+              <a:rPr lang="en-US" sz="1200" b="1">
                 <a:solidFill>
                   <a:srgbClr val="0F1419"/>
                 </a:solidFill>
@@ -7999,7 +8780,7 @@
               <a:t>System Requirements</a:t>
             </a:r>
             <a:r>
-              <a:rPr lang="en-US" sz="1200" dirty="0">
+              <a:rPr lang="en-US" sz="1200">
                 <a:solidFill>
                   <a:srgbClr val="0F1419"/>
                 </a:solidFill>
@@ -8010,7 +8791,7 @@
               <a:t>: Designed for Linux with NVIDIA GPUs using CUDA and </a:t>
             </a:r>
             <a:r>
-              <a:rPr lang="en-US" sz="1200" dirty="0" err="1">
+              <a:rPr lang="en-US" sz="1200" err="1">
                 <a:solidFill>
                   <a:srgbClr val="0F1419"/>
                 </a:solidFill>
@@ -8021,7 +8802,7 @@
               <a:t>PyTorch</a:t>
             </a:r>
             <a:r>
-              <a:rPr lang="en-US" sz="1200" dirty="0">
+              <a:rPr lang="en-US" sz="1200">
                 <a:solidFill>
                   <a:srgbClr val="0F1419"/>
                 </a:solidFill>
@@ -8032,7 +8813,7 @@
               <a:t>. CPU-only operation </a:t>
             </a:r>
             <a:r>
-              <a:rPr lang="en-US" sz="1200" b="1" dirty="0">
+              <a:rPr lang="en-US" sz="1200" b="1">
                 <a:solidFill>
                   <a:srgbClr val="0F1419"/>
                 </a:solidFill>
@@ -8043,7 +8824,7 @@
               <a:t>in theory </a:t>
             </a:r>
             <a:r>
-              <a:rPr lang="en-US" sz="1200" dirty="0">
+              <a:rPr lang="en-US" sz="1200">
                 <a:solidFill>
                   <a:srgbClr val="0F1419"/>
                 </a:solidFill>
@@ -8053,7 +8834,7 @@
               </a:rPr>
               <a:t>is not feasible for the current templates due to computational demands. I ran it on Intel i5 processor.</a:t>
             </a:r>
-            <a:endParaRPr lang="en-US" sz="1200" dirty="0">
+            <a:endParaRPr lang="en-US" sz="1200">
               <a:solidFill>
                 <a:srgbClr val="B5A9A1"/>
               </a:solidFill>
@@ -8071,7 +8852,7 @@
                 <a:spcPct val="0"/>
               </a:spcAft>
             </a:pPr>
-            <a:endParaRPr lang="en-US" sz="1200" dirty="0">
+            <a:endParaRPr lang="en-US" sz="1200">
               <a:solidFill>
                 <a:srgbClr val="B5A9A1"/>
               </a:solidFill>
@@ -8145,7 +8926,7 @@
               <a:t>Claude</a:t>
             </a:r>
             <a:r>
-              <a:rPr lang="en-US" sz="1200" dirty="0">
+              <a:rPr lang="en-US" sz="1200">
                 <a:solidFill>
                   <a:srgbClr val="0F1419"/>
                 </a:solidFill>
@@ -8211,7 +8992,7 @@
               <a:t>API</a:t>
             </a:r>
             <a:r>
-              <a:rPr lang="en-US" sz="1200" dirty="0">
+              <a:rPr lang="en-US" sz="1200">
                 <a:solidFill>
                   <a:srgbClr val="0F1419"/>
                 </a:solidFill>
@@ -8265,7 +9046,7 @@
               </a:rPr>
               <a:t>.</a:t>
             </a:r>
-            <a:endParaRPr lang="en-US" sz="1200" dirty="0">
+            <a:endParaRPr lang="en-US" sz="1200">
               <a:solidFill>
                 <a:srgbClr val="B5A9A1"/>
               </a:solidFill>
@@ -8283,7 +9064,7 @@
                 <a:spcPct val="0"/>
               </a:spcAft>
             </a:pPr>
-            <a:endParaRPr lang="en-US" sz="1200" dirty="0">
+            <a:endParaRPr lang="en-US" sz="1200">
               <a:solidFill>
                 <a:srgbClr val="B5A9A1"/>
               </a:solidFill>
@@ -8770,7 +9551,7 @@
             <a:pPr marL="0" indent="0" algn="ctr">
               <a:buNone/>
             </a:pPr>
-            <a:endParaRPr lang="en-US" sz="1800" b="1" dirty="0">
+            <a:endParaRPr lang="en-US" sz="1800" b="1">
               <a:solidFill>
                 <a:srgbClr val="B5A9A1"/>
               </a:solidFill>
@@ -8814,7 +9595,7 @@
                 <a:spcPct val="0"/>
               </a:spcAft>
             </a:pPr>
-            <a:endParaRPr lang="en-US" b="1" u="sng" dirty="0">
+            <a:endParaRPr lang="en-US" b="1" u="sng">
               <a:solidFill>
                 <a:srgbClr val="595959"/>
               </a:solidFill>
@@ -9342,15 +10123,16 @@
                             <a:srgbClr val="000000"/>
                           </a:solidFill>
                           <a:effectLst/>
-                          <a:latin typeface="Arial" panose="020B0604020202020204" pitchFamily="34" charset="0"/>
+                          <a:latin typeface="Arial"/>
                         </a:rPr>
-                        <a:t>Gemini CLI</a:t>
+                        <a:t>Antigravity CLI</a:t>
                       </a:r>
                       <a:endParaRPr lang="en-US" b="0" i="0">
                         <a:solidFill>
                           <a:srgbClr val="000000"/>
                         </a:solidFill>
                         <a:effectLst/>
+                        <a:latin typeface="Arial"/>
                       </a:endParaRPr>
                     </a:p>
                   </a:txBody>
@@ -9564,16 +10346,16 @@
                         <a:buNone/>
                       </a:pPr>
                       <a:r>
-                        <a:rPr lang="en-US" sz="1800" b="0" i="0">
+                        <a:rPr lang="en-US" sz="1800" b="0" i="0" err="1">
                           <a:solidFill>
                             <a:srgbClr val="000000"/>
                           </a:solidFill>
                           <a:effectLst/>
-                          <a:latin typeface="Arial" panose="020B0604020202020204" pitchFamily="34" charset="0"/>
+                          <a:latin typeface="Arial"/>
                         </a:rPr>
-                        <a:t>XAI</a:t>
+                        <a:t>xAI</a:t>
                       </a:r>
-                      <a:endParaRPr lang="en-US" b="0" i="0">
+                      <a:endParaRPr lang="en-US" b="0" i="0" err="1">
                         <a:solidFill>
                           <a:srgbClr val="000000"/>
                         </a:solidFill>
@@ -9886,37 +10668,6 @@
       </p:pic>
       <p:pic>
         <p:nvPicPr>
-          <p:cNvPr id="19" name="Picture 18" descr="A screenshot of a computer&#10;&#10;AI-generated content may be incorrect.">
-            <a:extLst>
-              <a:ext uri="{FF2B5EF4-FFF2-40B4-BE49-F238E27FC236}">
-                <a16:creationId xmlns:a16="http://schemas.microsoft.com/office/drawing/2014/main" id="{B3AF6E74-2D74-ACA5-C880-965BCBEA7BE3}"/>
-              </a:ext>
-            </a:extLst>
-          </p:cNvPr>
-          <p:cNvPicPr>
-            <a:picLocks noChangeAspect="1"/>
-          </p:cNvPicPr>
-          <p:nvPr/>
-        </p:nvPicPr>
-        <p:blipFill>
-          <a:blip r:embed="rId5"/>
-          <a:srcRect/>
-          <a:stretch>
-            <a:fillRect/>
-          </a:stretch>
-        </p:blipFill>
-        <p:spPr>
-          <a:xfrm>
-            <a:off x="4895748" y="4656003"/>
-            <a:ext cx="1476375" cy="885825"/>
-          </a:xfrm>
-          <a:prstGeom prst="rect">
-            <a:avLst/>
-          </a:prstGeom>
-        </p:spPr>
-      </p:pic>
-      <p:pic>
-        <p:nvPicPr>
           <p:cNvPr id="20" name="Picture 19" descr="A computer screen shot of a computer code&#10;&#10;AI-generated content may be incorrect.">
             <a:extLst>
               <a:ext uri="{FF2B5EF4-FFF2-40B4-BE49-F238E27FC236}">
@@ -9930,7 +10681,7 @@
           <p:nvPr/>
         </p:nvPicPr>
         <p:blipFill>
-          <a:blip r:embed="rId6"/>
+          <a:blip r:embed="rId5"/>
           <a:srcRect r="-380"/>
           <a:stretch>
             <a:fillRect/>
@@ -9961,7 +10712,7 @@
           <p:nvPr/>
         </p:nvPicPr>
         <p:blipFill>
-          <a:blip r:embed="rId7"/>
+          <a:blip r:embed="rId6"/>
           <a:srcRect r="377"/>
           <a:stretch>
             <a:fillRect/>
@@ -9971,6 +10722,36 @@
           <a:xfrm>
             <a:off x="8704026" y="4664109"/>
             <a:ext cx="1764965" cy="885825"/>
+          </a:xfrm>
+          <a:prstGeom prst="rect">
+            <a:avLst/>
+          </a:prstGeom>
+        </p:spPr>
+      </p:pic>
+      <p:pic>
+        <p:nvPicPr>
+          <p:cNvPr id="12" name="Picture 11" descr="A screenshot of a computer&#10;&#10;AI-generated content may be incorrect.">
+            <a:extLst>
+              <a:ext uri="{FF2B5EF4-FFF2-40B4-BE49-F238E27FC236}">
+                <a16:creationId xmlns:a16="http://schemas.microsoft.com/office/drawing/2014/main" id="{7610BC28-366A-D2D1-1735-AC56958137A9}"/>
+              </a:ext>
+            </a:extLst>
+          </p:cNvPr>
+          <p:cNvPicPr>
+            <a:picLocks noChangeAspect="1"/>
+          </p:cNvPicPr>
+          <p:nvPr/>
+        </p:nvPicPr>
+        <p:blipFill>
+          <a:blip r:embed="rId7"/>
+          <a:stretch>
+            <a:fillRect/>
+          </a:stretch>
+        </p:blipFill>
+        <p:spPr>
+          <a:xfrm>
+            <a:off x="4942461" y="4660462"/>
+            <a:ext cx="1439695" cy="901228"/>
           </a:xfrm>
           <a:prstGeom prst="rect">
             <a:avLst/>
@@ -10304,7 +11085,7 @@
             <a:pPr marL="0" indent="0" algn="ctr">
               <a:buNone/>
             </a:pPr>
-            <a:endParaRPr lang="en-US" sz="1800" b="1" dirty="0">
+            <a:endParaRPr lang="en-US" sz="1800" b="1">
               <a:solidFill>
                 <a:srgbClr val="B5A9A1"/>
               </a:solidFill>
@@ -10391,47 +11172,6 @@
                 <a:spcPct val="0"/>
               </a:spcAft>
             </a:pPr>
-            <a:endParaRPr lang="en-US" dirty="0">
-              <a:solidFill>
-                <a:srgbClr val="595959"/>
-              </a:solidFill>
-              <a:cs typeface="Arial"/>
-            </a:endParaRPr>
-          </a:p>
-          <a:p>
-            <a:pPr>
-              <a:spcBef>
-                <a:spcPct val="0"/>
-              </a:spcBef>
-              <a:spcAft>
-                <a:spcPct val="0"/>
-              </a:spcAft>
-            </a:pPr>
-            <a:endParaRPr lang="en-US" dirty="0">
-              <a:solidFill>
-                <a:srgbClr val="595959"/>
-              </a:solidFill>
-              <a:cs typeface="Arial"/>
-            </a:endParaRPr>
-          </a:p>
-          <a:p>
-            <a:pPr>
-              <a:spcBef>
-                <a:spcPct val="0"/>
-              </a:spcBef>
-              <a:spcAft>
-                <a:spcPct val="0"/>
-              </a:spcAft>
-            </a:pPr>
-            <a:r>
-              <a:rPr lang="en-US">
-                <a:solidFill>
-                  <a:srgbClr val="000000"/>
-                </a:solidFill>
-                <a:cs typeface="Arial"/>
-              </a:rPr>
-              <a:t>            # Comment                                          Prompt  </a:t>
-            </a:r>
             <a:endParaRPr lang="en-US">
               <a:solidFill>
                 <a:srgbClr val="595959"/>
@@ -10448,15 +11188,6 @@
                 <a:spcPct val="0"/>
               </a:spcAft>
             </a:pPr>
-            <a:r>
-              <a:rPr lang="en-US">
-                <a:solidFill>
-                  <a:srgbClr val="000000"/>
-                </a:solidFill>
-                <a:cs typeface="Arial"/>
-              </a:rPr>
-              <a:t>   </a:t>
-            </a:r>
             <a:endParaRPr lang="en-US">
               <a:solidFill>
                 <a:srgbClr val="595959"/>
@@ -10473,22 +11204,6 @@
                 <a:spcPct val="0"/>
               </a:spcAft>
             </a:pPr>
-            <a:endParaRPr lang="en-US" dirty="0">
-              <a:solidFill>
-                <a:srgbClr val="595959"/>
-              </a:solidFill>
-              <a:cs typeface="Arial"/>
-            </a:endParaRPr>
-          </a:p>
-          <a:p>
-            <a:pPr>
-              <a:spcBef>
-                <a:spcPct val="0"/>
-              </a:spcBef>
-              <a:spcAft>
-                <a:spcPct val="0"/>
-              </a:spcAft>
-            </a:pPr>
             <a:r>
               <a:rPr lang="en-US">
                 <a:solidFill>
@@ -10496,7 +11211,7 @@
                 </a:solidFill>
                 <a:cs typeface="Arial"/>
               </a:rPr>
-              <a:t>                 Code                                               Output</a:t>
+              <a:t>            # Comment                                          Prompt  </a:t>
             </a:r>
             <a:endParaRPr lang="en-US">
               <a:solidFill>
@@ -10514,38 +11229,6 @@
                 <a:spcPct val="0"/>
               </a:spcAft>
             </a:pPr>
-            <a:endParaRPr lang="en-US" dirty="0">
-              <a:solidFill>
-                <a:srgbClr val="595959"/>
-              </a:solidFill>
-              <a:cs typeface="Arial"/>
-            </a:endParaRPr>
-          </a:p>
-          <a:p>
-            <a:pPr>
-              <a:spcBef>
-                <a:spcPct val="0"/>
-              </a:spcBef>
-              <a:spcAft>
-                <a:spcPct val="0"/>
-              </a:spcAft>
-            </a:pPr>
-            <a:endParaRPr lang="en-US" dirty="0">
-              <a:solidFill>
-                <a:srgbClr val="595959"/>
-              </a:solidFill>
-              <a:cs typeface="Arial"/>
-            </a:endParaRPr>
-          </a:p>
-          <a:p>
-            <a:pPr>
-              <a:spcBef>
-                <a:spcPct val="0"/>
-              </a:spcBef>
-              <a:spcAft>
-                <a:spcPct val="0"/>
-              </a:spcAft>
-            </a:pPr>
             <a:r>
               <a:rPr lang="en-US">
                 <a:solidFill>
@@ -10553,7 +11236,7 @@
                 </a:solidFill>
                 <a:cs typeface="Arial"/>
               </a:rPr>
-              <a:t>                                                                  CTRL-C CTRL-V</a:t>
+              <a:t>   </a:t>
             </a:r>
             <a:endParaRPr lang="en-US">
               <a:solidFill>
@@ -10571,7 +11254,7 @@
                 <a:spcPct val="0"/>
               </a:spcAft>
             </a:pPr>
-            <a:endParaRPr lang="en-US" dirty="0">
+            <a:endParaRPr lang="en-US">
               <a:solidFill>
                 <a:srgbClr val="595959"/>
               </a:solidFill>
@@ -10587,7 +11270,105 @@
                 <a:spcPct val="0"/>
               </a:spcAft>
             </a:pPr>
-            <a:endParaRPr lang="en-US" dirty="0">
+            <a:r>
+              <a:rPr lang="en-US">
+                <a:solidFill>
+                  <a:srgbClr val="000000"/>
+                </a:solidFill>
+                <a:cs typeface="Arial"/>
+              </a:rPr>
+              <a:t>                 Code                                               Output</a:t>
+            </a:r>
+            <a:endParaRPr lang="en-US">
+              <a:solidFill>
+                <a:srgbClr val="595959"/>
+              </a:solidFill>
+              <a:cs typeface="Arial"/>
+            </a:endParaRPr>
+          </a:p>
+          <a:p>
+            <a:pPr>
+              <a:spcBef>
+                <a:spcPct val="0"/>
+              </a:spcBef>
+              <a:spcAft>
+                <a:spcPct val="0"/>
+              </a:spcAft>
+            </a:pPr>
+            <a:endParaRPr lang="en-US">
+              <a:solidFill>
+                <a:srgbClr val="595959"/>
+              </a:solidFill>
+              <a:cs typeface="Arial"/>
+            </a:endParaRPr>
+          </a:p>
+          <a:p>
+            <a:pPr>
+              <a:spcBef>
+                <a:spcPct val="0"/>
+              </a:spcBef>
+              <a:spcAft>
+                <a:spcPct val="0"/>
+              </a:spcAft>
+            </a:pPr>
+            <a:endParaRPr lang="en-US">
+              <a:solidFill>
+                <a:srgbClr val="595959"/>
+              </a:solidFill>
+              <a:cs typeface="Arial"/>
+            </a:endParaRPr>
+          </a:p>
+          <a:p>
+            <a:pPr>
+              <a:spcBef>
+                <a:spcPct val="0"/>
+              </a:spcBef>
+              <a:spcAft>
+                <a:spcPct val="0"/>
+              </a:spcAft>
+            </a:pPr>
+            <a:r>
+              <a:rPr lang="en-US">
+                <a:solidFill>
+                  <a:srgbClr val="000000"/>
+                </a:solidFill>
+                <a:cs typeface="Arial"/>
+              </a:rPr>
+              <a:t>                                                                  CTRL-C CTRL-V</a:t>
+            </a:r>
+            <a:endParaRPr lang="en-US">
+              <a:solidFill>
+                <a:srgbClr val="595959"/>
+              </a:solidFill>
+              <a:cs typeface="Arial"/>
+            </a:endParaRPr>
+          </a:p>
+          <a:p>
+            <a:pPr>
+              <a:spcBef>
+                <a:spcPct val="0"/>
+              </a:spcBef>
+              <a:spcAft>
+                <a:spcPct val="0"/>
+              </a:spcAft>
+            </a:pPr>
+            <a:endParaRPr lang="en-US">
+              <a:solidFill>
+                <a:srgbClr val="595959"/>
+              </a:solidFill>
+              <a:cs typeface="Arial"/>
+            </a:endParaRPr>
+          </a:p>
+          <a:p>
+            <a:pPr>
+              <a:spcBef>
+                <a:spcPct val="0"/>
+              </a:spcBef>
+              <a:spcAft>
+                <a:spcPct val="0"/>
+              </a:spcAft>
+            </a:pPr>
+            <a:endParaRPr lang="en-US">
               <a:solidFill>
                 <a:srgbClr val="595959"/>
               </a:solidFill>
@@ -11613,7 +12394,7 @@
           <a:p>
             <a:pPr algn="ctr"/>
             <a:r>
-              <a:rPr lang="en-US" sz="2800" b="1" i="0" u="none" strike="noStrike" baseline="0" dirty="0">
+              <a:rPr lang="en-US" sz="2800" b="1" i="0" u="none" strike="noStrike" baseline="0">
                 <a:solidFill>
                   <a:srgbClr val="000000"/>
                 </a:solidFill>
@@ -11622,7 +12403,7 @@
               <a:t>Agentic AI</a:t>
             </a:r>
             <a:r>
-              <a:rPr lang="en-US" sz="2800" b="1" dirty="0">
+              <a:rPr lang="en-US" sz="2800" b="1">
                 <a:solidFill>
                   <a:srgbClr val="000000"/>
                 </a:solidFill>
@@ -11708,7 +12489,7 @@
             <a:pPr marL="0" indent="0" algn="ctr">
               <a:buNone/>
             </a:pPr>
-            <a:endParaRPr lang="en-US" sz="1800" b="1" dirty="0">
+            <a:endParaRPr lang="en-US" sz="1800" b="1">
               <a:solidFill>
                 <a:srgbClr val="B5A9A1"/>
               </a:solidFill>
@@ -11762,7 +12543,7 @@
               <a:t>Actions</a:t>
             </a:r>
             <a:r>
-              <a:rPr lang="en-US" sz="1600" dirty="0">
+              <a:rPr lang="en-US" sz="1600">
                 <a:solidFill>
                   <a:srgbClr val="000000"/>
                 </a:solidFill>
@@ -11770,7 +12551,7 @@
               </a:rPr>
               <a:t> </a:t>
             </a:r>
-            <a:endParaRPr lang="en-US" sz="1600" dirty="0">
+            <a:endParaRPr lang="en-US" sz="1600">
               <a:solidFill>
                 <a:srgbClr val="595959"/>
               </a:solidFill>
@@ -11795,7 +12576,7 @@
               </a:rPr>
               <a:t>Literature Survey, Experiment Design, Execution, Evaluation, Write-up</a:t>
             </a:r>
-            <a:endParaRPr lang="en-US" sz="1600" dirty="0">
+            <a:endParaRPr lang="en-US" sz="1600">
               <a:solidFill>
                 <a:srgbClr val="595959"/>
               </a:solidFill>
@@ -11811,7 +12592,7 @@
                 <a:spcPct val="0"/>
               </a:spcAft>
             </a:pPr>
-            <a:endParaRPr lang="en-US" sz="1600" dirty="0">
+            <a:endParaRPr lang="en-US" sz="1600">
               <a:solidFill>
                 <a:srgbClr val="595959"/>
               </a:solidFill>
@@ -11837,7 +12618,7 @@
               <a:t>Context/Planning</a:t>
             </a:r>
             <a:r>
-              <a:rPr lang="en-US" sz="1600" dirty="0">
+              <a:rPr lang="en-US" sz="1600">
                 <a:solidFill>
                   <a:srgbClr val="000000"/>
                 </a:solidFill>
@@ -11845,7 +12626,7 @@
               </a:rPr>
               <a:t> </a:t>
             </a:r>
-            <a:endParaRPr lang="en-US" sz="1600" dirty="0">
+            <a:endParaRPr lang="en-US" sz="1600">
               <a:solidFill>
                 <a:srgbClr val="595959"/>
               </a:solidFill>
@@ -11862,7 +12643,7 @@
               </a:spcAft>
             </a:pPr>
             <a:r>
-              <a:rPr lang="en-US" sz="1600" dirty="0">
+              <a:rPr lang="en-US" sz="1600">
                 <a:solidFill>
                   <a:srgbClr val="000000"/>
                 </a:solidFill>
@@ -11870,7 +12651,7 @@
               </a:rPr>
               <a:t>Queues e.g. FIFO, prompt history, log, memory </a:t>
             </a:r>
-            <a:endParaRPr lang="en-US" sz="1600" dirty="0">
+            <a:endParaRPr lang="en-US" sz="1600">
               <a:solidFill>
                 <a:srgbClr val="595959"/>
               </a:solidFill>
@@ -11886,7 +12667,7 @@
                 <a:spcPct val="0"/>
               </a:spcAft>
             </a:pPr>
-            <a:endParaRPr lang="en-US" sz="1600" dirty="0">
+            <a:endParaRPr lang="en-US" sz="1600">
               <a:solidFill>
                 <a:srgbClr val="595959"/>
               </a:solidFill>
@@ -11911,7 +12692,7 @@
               </a:rPr>
               <a:t>Tools</a:t>
             </a:r>
-            <a:endParaRPr lang="en-US" sz="1600" dirty="0">
+            <a:endParaRPr lang="en-US" sz="1600">
               <a:solidFill>
                 <a:srgbClr val="595959"/>
               </a:solidFill>
@@ -11928,7 +12709,7 @@
               </a:spcAft>
             </a:pPr>
             <a:r>
-              <a:rPr lang="en-US" sz="1600" dirty="0">
+              <a:rPr lang="en-US" sz="1600">
                 <a:solidFill>
                   <a:srgbClr val="000000"/>
                 </a:solidFill>
@@ -11937,7 +12718,7 @@
               <a:t>Semantic Scholar/</a:t>
             </a:r>
             <a:r>
-              <a:rPr lang="en-US" sz="1600" dirty="0" err="1">
+              <a:rPr lang="en-US" sz="1600" err="1">
                 <a:solidFill>
                   <a:srgbClr val="000000"/>
                 </a:solidFill>
@@ -11946,7 +12727,7 @@
               <a:t>ArXiv</a:t>
             </a:r>
             <a:r>
-              <a:rPr lang="en-US" sz="1600" dirty="0">
+              <a:rPr lang="en-US" sz="1600">
                 <a:solidFill>
                   <a:srgbClr val="000000"/>
                 </a:solidFill>
@@ -11954,7 +12735,7 @@
               </a:rPr>
               <a:t>  API/MCP   Python/Bash   Latex</a:t>
             </a:r>
-            <a:endParaRPr lang="en-US" sz="1600" dirty="0">
+            <a:endParaRPr lang="en-US" sz="1600">
               <a:solidFill>
                 <a:srgbClr val="595959"/>
               </a:solidFill>
@@ -11970,7 +12751,7 @@
                 <a:spcPct val="0"/>
               </a:spcAft>
             </a:pPr>
-            <a:endParaRPr lang="en-US" sz="1600" dirty="0">
+            <a:endParaRPr lang="en-US" sz="1600">
               <a:solidFill>
                 <a:srgbClr val="595959"/>
               </a:solidFill>
@@ -11995,7 +12776,7 @@
               </a:rPr>
               <a:t>Safety Net</a:t>
             </a:r>
-            <a:endParaRPr lang="en-US" sz="1600" dirty="0">
+            <a:endParaRPr lang="en-US" sz="1600">
               <a:solidFill>
                 <a:srgbClr val="595959"/>
               </a:solidFill>
@@ -12018,18 +12799,9 @@
                 </a:solidFill>
                 <a:cs typeface="Arial"/>
               </a:rPr>
-              <a:t>Regex, grep – check GenAI/LLM text/string exist in </a:t>
-            </a:r>
-            <a:r>
-              <a:rPr lang="en-US" sz="1600" dirty="0">
-                <a:solidFill>
-                  <a:srgbClr val="000000"/>
-                </a:solidFill>
-                <a:cs typeface="Arial"/>
-              </a:rPr>
-              <a:t>source</a:t>
-            </a:r>
-            <a:endParaRPr lang="en-US" sz="1600" dirty="0">
+              <a:t>Regex, grep – check GenAI/LLM text/string exist in source</a:t>
+            </a:r>
+            <a:endParaRPr lang="en-US" sz="1600">
               <a:solidFill>
                 <a:srgbClr val="595959"/>
               </a:solidFill>
@@ -12045,7 +12817,7 @@
                 <a:spcPct val="0"/>
               </a:spcAft>
             </a:pPr>
-            <a:endParaRPr lang="en-US" sz="1600" dirty="0">
+            <a:endParaRPr lang="en-US" sz="1600">
               <a:solidFill>
                 <a:srgbClr val="595959"/>
               </a:solidFill>
@@ -12070,7 +12842,7 @@
               </a:rPr>
               <a:t>Agent Agnostic</a:t>
             </a:r>
-            <a:endParaRPr lang="en-US" sz="1600" dirty="0">
+            <a:endParaRPr lang="en-US" sz="1600">
               <a:solidFill>
                 <a:srgbClr val="595959"/>
               </a:solidFill>
@@ -12093,9 +12865,9 @@
                 </a:solidFill>
                 <a:cs typeface="Arial"/>
               </a:rPr>
-              <a:t>Well established workflows that work with any provider</a:t>
-            </a:r>
-            <a:endParaRPr lang="en-US" sz="1600" dirty="0">
+              <a:t>Well established workflow that works with any provider</a:t>
+            </a:r>
+            <a:endParaRPr lang="en-US" sz="1600">
               <a:solidFill>
                 <a:srgbClr val="595959"/>
               </a:solidFill>
@@ -12111,7 +12883,7 @@
                 <a:spcPct val="0"/>
               </a:spcAft>
             </a:pPr>
-            <a:endParaRPr lang="en-US" sz="1600" dirty="0">
+            <a:endParaRPr lang="en-US" sz="1600">
               <a:solidFill>
                 <a:srgbClr val="595959"/>
               </a:solidFill>
@@ -12136,7 +12908,7 @@
               </a:rPr>
               <a:t>Coder becomes Manager (Industry trend)</a:t>
             </a:r>
-            <a:endParaRPr lang="en-US" sz="1600" dirty="0">
+            <a:endParaRPr lang="en-US" sz="1600">
               <a:solidFill>
                 <a:srgbClr val="595959"/>
               </a:solidFill>
@@ -12345,7 +13117,7 @@
         </p:nvSpPr>
         <p:spPr>
           <a:xfrm>
-            <a:off x="2286000" y="0"/>
+            <a:off x="2438400" y="-94343"/>
             <a:ext cx="9905695" cy="6858000"/>
           </a:xfrm>
           <a:prstGeom prst="rect">
@@ -12468,7 +13240,7 @@
         </p:nvSpPr>
         <p:spPr>
           <a:xfrm>
-            <a:off x="2743200" y="749808"/>
+            <a:off x="2743200" y="640951"/>
             <a:ext cx="8183880" cy="438912"/>
           </a:xfrm>
           <a:prstGeom prst="rect">
@@ -12592,7 +13364,7 @@
             <a:pPr marL="0" indent="0" algn="ctr">
               <a:buNone/>
             </a:pPr>
-            <a:endParaRPr lang="en-US" sz="1800" b="1" dirty="0">
+            <a:endParaRPr lang="en-US" sz="1800" b="1">
               <a:solidFill>
                 <a:srgbClr val="B5A9A1"/>
               </a:solidFill>
@@ -12686,79 +13458,6 @@
                 <a:spcPct val="0"/>
               </a:spcAft>
             </a:pPr>
-            <a:endParaRPr lang="en-US" dirty="0">
-              <a:solidFill>
-                <a:srgbClr val="595959"/>
-              </a:solidFill>
-              <a:cs typeface="Arial"/>
-            </a:endParaRPr>
-          </a:p>
-          <a:p>
-            <a:pPr>
-              <a:spcBef>
-                <a:spcPct val="0"/>
-              </a:spcBef>
-              <a:spcAft>
-                <a:spcPct val="0"/>
-              </a:spcAft>
-            </a:pPr>
-            <a:endParaRPr lang="en-US" dirty="0">
-              <a:solidFill>
-                <a:srgbClr val="595959"/>
-              </a:solidFill>
-              <a:cs typeface="Arial"/>
-            </a:endParaRPr>
-          </a:p>
-          <a:p>
-            <a:pPr>
-              <a:spcBef>
-                <a:spcPct val="0"/>
-              </a:spcBef>
-              <a:spcAft>
-                <a:spcPct val="0"/>
-              </a:spcAft>
-            </a:pPr>
-            <a:endParaRPr lang="en-US" dirty="0">
-              <a:solidFill>
-                <a:srgbClr val="595959"/>
-              </a:solidFill>
-              <a:cs typeface="Arial"/>
-            </a:endParaRPr>
-          </a:p>
-          <a:p>
-            <a:pPr>
-              <a:spcBef>
-                <a:spcPct val="0"/>
-              </a:spcBef>
-              <a:spcAft>
-                <a:spcPct val="0"/>
-              </a:spcAft>
-            </a:pPr>
-            <a:endParaRPr lang="en-US" dirty="0">
-              <a:solidFill>
-                <a:srgbClr val="595959"/>
-              </a:solidFill>
-              <a:cs typeface="Arial"/>
-            </a:endParaRPr>
-          </a:p>
-          <a:p>
-            <a:pPr>
-              <a:spcBef>
-                <a:spcPct val="0"/>
-              </a:spcBef>
-              <a:spcAft>
-                <a:spcPct val="0"/>
-              </a:spcAft>
-            </a:pPr>
-            <a:r>
-              <a:rPr lang="en-US" b="1">
-                <a:solidFill>
-                  <a:srgbClr val="000000"/>
-                </a:solidFill>
-                <a:cs typeface="Arial"/>
-              </a:rPr>
-              <a:t>Training and baseline solution provided</a:t>
-            </a:r>
             <a:endParaRPr lang="en-US">
               <a:solidFill>
                 <a:srgbClr val="595959"/>
@@ -12775,15 +13474,6 @@
                 <a:spcPct val="0"/>
               </a:spcAft>
             </a:pPr>
-            <a:r>
-              <a:rPr lang="en-US">
-                <a:solidFill>
-                  <a:srgbClr val="000000"/>
-                </a:solidFill>
-                <a:cs typeface="Arial"/>
-              </a:rPr>
-              <a:t>To be improved, with the use of AI Agents, by participating teams</a:t>
-            </a:r>
             <a:endParaRPr lang="en-US">
               <a:solidFill>
                 <a:srgbClr val="595959"/>
@@ -12800,31 +13490,6 @@
                 <a:spcPct val="0"/>
               </a:spcAft>
             </a:pPr>
-            <a:endParaRPr lang="en-US" dirty="0">
-              <a:solidFill>
-                <a:srgbClr val="595959"/>
-              </a:solidFill>
-              <a:cs typeface="Arial"/>
-            </a:endParaRPr>
-          </a:p>
-          <a:p>
-            <a:pPr>
-              <a:spcBef>
-                <a:spcPct val="0"/>
-              </a:spcBef>
-              <a:spcAft>
-                <a:spcPct val="0"/>
-              </a:spcAft>
-            </a:pPr>
-            <a:r>
-              <a:rPr lang="en-US" b="1">
-                <a:solidFill>
-                  <a:srgbClr val="000000"/>
-                </a:solidFill>
-                <a:cs typeface="Arial"/>
-              </a:rPr>
-              <a:t>Numbers</a:t>
-            </a:r>
             <a:endParaRPr lang="en-US">
               <a:solidFill>
                 <a:srgbClr val="595959"/>
@@ -12841,15 +13506,6 @@
                 <a:spcPct val="0"/>
               </a:spcAft>
             </a:pPr>
-            <a:r>
-              <a:rPr lang="en-US">
-                <a:solidFill>
-                  <a:srgbClr val="000000"/>
-                </a:solidFill>
-                <a:cs typeface="Arial"/>
-              </a:rPr>
-              <a:t>76 sign-ups (majority PG), 32 finalists, 9 teams</a:t>
-            </a:r>
             <a:endParaRPr lang="en-US">
               <a:solidFill>
                 <a:srgbClr val="595959"/>
@@ -12866,7 +13522,123 @@
                 <a:spcPct val="0"/>
               </a:spcAft>
             </a:pPr>
-            <a:endParaRPr lang="en-US" dirty="0">
+            <a:r>
+              <a:rPr lang="en-US" b="1">
+                <a:solidFill>
+                  <a:srgbClr val="000000"/>
+                </a:solidFill>
+                <a:cs typeface="Arial"/>
+              </a:rPr>
+              <a:t>Training and baseline solution provided</a:t>
+            </a:r>
+            <a:endParaRPr lang="en-US">
+              <a:solidFill>
+                <a:srgbClr val="595959"/>
+              </a:solidFill>
+              <a:cs typeface="Arial"/>
+            </a:endParaRPr>
+          </a:p>
+          <a:p>
+            <a:pPr>
+              <a:spcBef>
+                <a:spcPct val="0"/>
+              </a:spcBef>
+              <a:spcAft>
+                <a:spcPct val="0"/>
+              </a:spcAft>
+            </a:pPr>
+            <a:r>
+              <a:rPr lang="en-US">
+                <a:solidFill>
+                  <a:srgbClr val="000000"/>
+                </a:solidFill>
+                <a:cs typeface="Arial"/>
+              </a:rPr>
+              <a:t>To be improved, with the use of AI Agents, by participating teams</a:t>
+            </a:r>
+            <a:endParaRPr lang="en-US">
+              <a:solidFill>
+                <a:srgbClr val="595959"/>
+              </a:solidFill>
+              <a:cs typeface="Arial"/>
+            </a:endParaRPr>
+          </a:p>
+          <a:p>
+            <a:pPr>
+              <a:spcBef>
+                <a:spcPct val="0"/>
+              </a:spcBef>
+              <a:spcAft>
+                <a:spcPct val="0"/>
+              </a:spcAft>
+            </a:pPr>
+            <a:endParaRPr lang="en-US">
+              <a:solidFill>
+                <a:srgbClr val="595959"/>
+              </a:solidFill>
+              <a:cs typeface="Arial"/>
+            </a:endParaRPr>
+          </a:p>
+          <a:p>
+            <a:pPr>
+              <a:spcBef>
+                <a:spcPct val="0"/>
+              </a:spcBef>
+              <a:spcAft>
+                <a:spcPct val="0"/>
+              </a:spcAft>
+            </a:pPr>
+            <a:r>
+              <a:rPr lang="en-US" b="1">
+                <a:solidFill>
+                  <a:srgbClr val="000000"/>
+                </a:solidFill>
+                <a:cs typeface="Arial"/>
+              </a:rPr>
+              <a:t>Numbers</a:t>
+            </a:r>
+            <a:endParaRPr lang="en-US">
+              <a:solidFill>
+                <a:srgbClr val="595959"/>
+              </a:solidFill>
+              <a:cs typeface="Arial"/>
+            </a:endParaRPr>
+          </a:p>
+          <a:p>
+            <a:pPr>
+              <a:spcBef>
+                <a:spcPct val="0"/>
+              </a:spcBef>
+              <a:spcAft>
+                <a:spcPct val="0"/>
+              </a:spcAft>
+            </a:pPr>
+            <a:r>
+              <a:rPr lang="en-US">
+                <a:solidFill>
+                  <a:srgbClr val="000000"/>
+                </a:solidFill>
+                <a:cs typeface="Arial"/>
+              </a:rPr>
+              <a:t>76 sign-ups (majority PG), 32 finalists, 9 teams</a:t>
+            </a:r>
+            <a:endParaRPr lang="en-US">
+              <a:solidFill>
+                <a:srgbClr val="595959"/>
+              </a:solidFill>
+              <a:cs typeface="Arial"/>
+            </a:endParaRPr>
+          </a:p>
+          <a:p>
+            <a:pPr>
+              <a:spcBef>
+                <a:spcPct val="0"/>
+              </a:spcBef>
+              <a:spcAft>
+                <a:spcPct val="0"/>
+              </a:spcAft>
+            </a:pPr>
+            <a:endParaRPr lang="en-US">
               <a:solidFill>
                 <a:srgbClr val="595959"/>
               </a:solidFill>
@@ -13278,6 +14050,328 @@
           </a:prstGeom>
         </p:spPr>
       </p:pic>
+      <p:grpSp>
+        <p:nvGrpSpPr>
+          <p:cNvPr id="16" name="Group 15">
+            <a:extLst>
+              <a:ext uri="{FF2B5EF4-FFF2-40B4-BE49-F238E27FC236}">
+                <a16:creationId xmlns:a16="http://schemas.microsoft.com/office/drawing/2014/main" id="{515F233D-2AAD-EB22-F515-84960BCBE2BE}"/>
+              </a:ext>
+            </a:extLst>
+          </p:cNvPr>
+          <p:cNvGrpSpPr/>
+          <p:nvPr/>
+        </p:nvGrpSpPr>
+        <p:grpSpPr>
+          <a:xfrm>
+            <a:off x="9141720" y="5995705"/>
+            <a:ext cx="2989243" cy="783793"/>
+            <a:chOff x="9141720" y="5995705"/>
+            <a:chExt cx="2989243" cy="783793"/>
+          </a:xfrm>
+        </p:grpSpPr>
+        <p:pic>
+          <p:nvPicPr>
+            <p:cNvPr id="17" name="Picture 16">
+              <a:extLst>
+                <a:ext uri="{FF2B5EF4-FFF2-40B4-BE49-F238E27FC236}">
+                  <a16:creationId xmlns:a16="http://schemas.microsoft.com/office/drawing/2014/main" id="{31E2BC46-02AB-C651-6BBD-F773E552A005}"/>
+                </a:ext>
+              </a:extLst>
+            </p:cNvPr>
+            <p:cNvPicPr>
+              <a:picLocks noChangeAspect="1"/>
+            </p:cNvPicPr>
+            <p:nvPr/>
+          </p:nvPicPr>
+          <p:blipFill>
+            <a:blip r:embed="rId7"/>
+            <a:srcRect b="17602"/>
+            <a:stretch/>
+          </p:blipFill>
+          <p:spPr>
+            <a:xfrm>
+              <a:off x="9141720" y="5995705"/>
+              <a:ext cx="2212144" cy="783793"/>
+            </a:xfrm>
+            <a:prstGeom prst="rect">
+              <a:avLst/>
+            </a:prstGeom>
+          </p:spPr>
+        </p:pic>
+        <p:pic>
+          <p:nvPicPr>
+            <p:cNvPr id="18" name="Picture 17">
+              <a:extLst>
+                <a:ext uri="{FF2B5EF4-FFF2-40B4-BE49-F238E27FC236}">
+                  <a16:creationId xmlns:a16="http://schemas.microsoft.com/office/drawing/2014/main" id="{65F8A102-709F-E62A-3544-3F2D41DAF5EB}"/>
+                </a:ext>
+              </a:extLst>
+            </p:cNvPr>
+            <p:cNvPicPr>
+              <a:picLocks noChangeAspect="1"/>
+            </p:cNvPicPr>
+            <p:nvPr/>
+          </p:nvPicPr>
+          <p:blipFill>
+            <a:blip r:embed="rId8" cstate="print">
+              <a:extLst>
+                <a:ext uri="{28A0092B-C50C-407E-A947-70E740481C1C}">
+                  <a14:useLocalDpi xmlns:a14="http://schemas.microsoft.com/office/drawing/2010/main" val="0"/>
+                </a:ext>
+              </a:extLst>
+            </a:blip>
+            <a:srcRect t="-629" b="370"/>
+            <a:stretch/>
+          </p:blipFill>
+          <p:spPr>
+            <a:xfrm>
+              <a:off x="11336367" y="5995705"/>
+              <a:ext cx="794596" cy="783793"/>
+            </a:xfrm>
+            <a:prstGeom prst="rect">
+              <a:avLst/>
+            </a:prstGeom>
+            <a:solidFill>
+              <a:schemeClr val="bg1"/>
+            </a:solidFill>
+          </p:spPr>
+        </p:pic>
+      </p:grpSp>
+      <p:grpSp>
+        <p:nvGrpSpPr>
+          <p:cNvPr id="19" name="Group 18">
+            <a:extLst>
+              <a:ext uri="{FF2B5EF4-FFF2-40B4-BE49-F238E27FC236}">
+                <a16:creationId xmlns:a16="http://schemas.microsoft.com/office/drawing/2014/main" id="{6A3FB7BE-A429-9F7E-75FC-5E37EA13C3EE}"/>
+              </a:ext>
+            </a:extLst>
+          </p:cNvPr>
+          <p:cNvGrpSpPr/>
+          <p:nvPr/>
+        </p:nvGrpSpPr>
+        <p:grpSpPr>
+          <a:xfrm>
+            <a:off x="9141720" y="5995705"/>
+            <a:ext cx="2989243" cy="783793"/>
+            <a:chOff x="9141720" y="5995705"/>
+            <a:chExt cx="2989243" cy="783793"/>
+          </a:xfrm>
+        </p:grpSpPr>
+        <p:pic>
+          <p:nvPicPr>
+            <p:cNvPr id="20" name="Picture 19">
+              <a:extLst>
+                <a:ext uri="{FF2B5EF4-FFF2-40B4-BE49-F238E27FC236}">
+                  <a16:creationId xmlns:a16="http://schemas.microsoft.com/office/drawing/2014/main" id="{BF83C038-EF17-1143-51B8-F3487BB37CAB}"/>
+                </a:ext>
+              </a:extLst>
+            </p:cNvPr>
+            <p:cNvPicPr>
+              <a:picLocks noChangeAspect="1"/>
+            </p:cNvPicPr>
+            <p:nvPr/>
+          </p:nvPicPr>
+          <p:blipFill>
+            <a:blip r:embed="rId7"/>
+            <a:srcRect b="17602"/>
+            <a:stretch/>
+          </p:blipFill>
+          <p:spPr>
+            <a:xfrm>
+              <a:off x="9141720" y="5995705"/>
+              <a:ext cx="2212144" cy="783793"/>
+            </a:xfrm>
+            <a:prstGeom prst="rect">
+              <a:avLst/>
+            </a:prstGeom>
+          </p:spPr>
+        </p:pic>
+        <p:pic>
+          <p:nvPicPr>
+            <p:cNvPr id="21" name="Picture 20">
+              <a:extLst>
+                <a:ext uri="{FF2B5EF4-FFF2-40B4-BE49-F238E27FC236}">
+                  <a16:creationId xmlns:a16="http://schemas.microsoft.com/office/drawing/2014/main" id="{12A3CC3B-ED86-D4A7-4ED0-0E6CC32B223D}"/>
+                </a:ext>
+              </a:extLst>
+            </p:cNvPr>
+            <p:cNvPicPr>
+              <a:picLocks noChangeAspect="1"/>
+            </p:cNvPicPr>
+            <p:nvPr/>
+          </p:nvPicPr>
+          <p:blipFill>
+            <a:blip r:embed="rId8" cstate="print">
+              <a:extLst>
+                <a:ext uri="{28A0092B-C50C-407E-A947-70E740481C1C}">
+                  <a14:useLocalDpi xmlns:a14="http://schemas.microsoft.com/office/drawing/2010/main" val="0"/>
+                </a:ext>
+              </a:extLst>
+            </a:blip>
+            <a:srcRect t="-629" b="370"/>
+            <a:stretch/>
+          </p:blipFill>
+          <p:spPr>
+            <a:xfrm>
+              <a:off x="11336367" y="5995705"/>
+              <a:ext cx="794596" cy="783793"/>
+            </a:xfrm>
+            <a:prstGeom prst="rect">
+              <a:avLst/>
+            </a:prstGeom>
+            <a:solidFill>
+              <a:schemeClr val="bg1"/>
+            </a:solidFill>
+          </p:spPr>
+        </p:pic>
+      </p:grpSp>
+      <p:sp>
+        <p:nvSpPr>
+          <p:cNvPr id="22" name="Text 3">
+            <a:extLst>
+              <a:ext uri="{FF2B5EF4-FFF2-40B4-BE49-F238E27FC236}">
+                <a16:creationId xmlns:a16="http://schemas.microsoft.com/office/drawing/2014/main" id="{D17C9F6F-C293-877A-220E-79845BB9A486}"/>
+              </a:ext>
+            </a:extLst>
+          </p:cNvPr>
+          <p:cNvSpPr/>
+          <p:nvPr/>
+        </p:nvSpPr>
+        <p:spPr>
+          <a:xfrm>
+            <a:off x="2756848" y="974109"/>
+            <a:ext cx="8183880" cy="438912"/>
+          </a:xfrm>
+          <a:prstGeom prst="rect">
+            <a:avLst/>
+          </a:prstGeom>
+          <a:noFill/>
+          <a:ln/>
+        </p:spPr>
+        <p:txBody>
+          <a:bodyPr wrap="square" lIns="0" tIns="0" rIns="0" bIns="0" rtlCol="0" anchor="ctr">
+            <a:normAutofit/>
+          </a:bodyPr>
+          <a:lstStyle>
+            <a:defPPr>
+              <a:defRPr lang="en-US"/>
+            </a:defPPr>
+            <a:lvl1pPr marL="0" algn="l" defTabSz="914400" rtl="0" eaLnBrk="1" latinLnBrk="0" hangingPunct="1">
+              <a:defRPr sz="1800" kern="1200">
+                <a:solidFill>
+                  <a:schemeClr val="tx1"/>
+                </a:solidFill>
+                <a:latin typeface="+mn-lt"/>
+                <a:ea typeface="+mn-ea"/>
+                <a:cs typeface="+mn-cs"/>
+              </a:defRPr>
+            </a:lvl1pPr>
+            <a:lvl2pPr marL="457200" algn="l" defTabSz="914400" rtl="0" eaLnBrk="1" latinLnBrk="0" hangingPunct="1">
+              <a:defRPr sz="1800" kern="1200">
+                <a:solidFill>
+                  <a:schemeClr val="tx1"/>
+                </a:solidFill>
+                <a:latin typeface="+mn-lt"/>
+                <a:ea typeface="+mn-ea"/>
+                <a:cs typeface="+mn-cs"/>
+              </a:defRPr>
+            </a:lvl2pPr>
+            <a:lvl3pPr marL="914400" algn="l" defTabSz="914400" rtl="0" eaLnBrk="1" latinLnBrk="0" hangingPunct="1">
+              <a:defRPr sz="1800" kern="1200">
+                <a:solidFill>
+                  <a:schemeClr val="tx1"/>
+                </a:solidFill>
+                <a:latin typeface="+mn-lt"/>
+                <a:ea typeface="+mn-ea"/>
+                <a:cs typeface="+mn-cs"/>
+              </a:defRPr>
+            </a:lvl3pPr>
+            <a:lvl4pPr marL="1371600" algn="l" defTabSz="914400" rtl="0" eaLnBrk="1" latinLnBrk="0" hangingPunct="1">
+              <a:defRPr sz="1800" kern="1200">
+                <a:solidFill>
+                  <a:schemeClr val="tx1"/>
+                </a:solidFill>
+                <a:latin typeface="+mn-lt"/>
+                <a:ea typeface="+mn-ea"/>
+                <a:cs typeface="+mn-cs"/>
+              </a:defRPr>
+            </a:lvl4pPr>
+            <a:lvl5pPr marL="1828800" algn="l" defTabSz="914400" rtl="0" eaLnBrk="1" latinLnBrk="0" hangingPunct="1">
+              <a:defRPr sz="1800" kern="1200">
+                <a:solidFill>
+                  <a:schemeClr val="tx1"/>
+                </a:solidFill>
+                <a:latin typeface="+mn-lt"/>
+                <a:ea typeface="+mn-ea"/>
+                <a:cs typeface="+mn-cs"/>
+              </a:defRPr>
+            </a:lvl5pPr>
+            <a:lvl6pPr marL="2286000" algn="l" defTabSz="914400" rtl="0" eaLnBrk="1" latinLnBrk="0" hangingPunct="1">
+              <a:defRPr sz="1800" kern="1200">
+                <a:solidFill>
+                  <a:schemeClr val="tx1"/>
+                </a:solidFill>
+                <a:latin typeface="+mn-lt"/>
+                <a:ea typeface="+mn-ea"/>
+                <a:cs typeface="+mn-cs"/>
+              </a:defRPr>
+            </a:lvl6pPr>
+            <a:lvl7pPr marL="2743200" algn="l" defTabSz="914400" rtl="0" eaLnBrk="1" latinLnBrk="0" hangingPunct="1">
+              <a:defRPr sz="1800" kern="1200">
+                <a:solidFill>
+                  <a:schemeClr val="tx1"/>
+                </a:solidFill>
+                <a:latin typeface="+mn-lt"/>
+                <a:ea typeface="+mn-ea"/>
+                <a:cs typeface="+mn-cs"/>
+              </a:defRPr>
+            </a:lvl7pPr>
+            <a:lvl8pPr marL="3200400" algn="l" defTabSz="914400" rtl="0" eaLnBrk="1" latinLnBrk="0" hangingPunct="1">
+              <a:defRPr sz="1800" kern="1200">
+                <a:solidFill>
+                  <a:schemeClr val="tx1"/>
+                </a:solidFill>
+                <a:latin typeface="+mn-lt"/>
+                <a:ea typeface="+mn-ea"/>
+                <a:cs typeface="+mn-cs"/>
+              </a:defRPr>
+            </a:lvl8pPr>
+            <a:lvl9pPr marL="3657600" algn="l" defTabSz="914400" rtl="0" eaLnBrk="1" latinLnBrk="0" hangingPunct="1">
+              <a:defRPr sz="1800" kern="1200">
+                <a:solidFill>
+                  <a:schemeClr val="tx1"/>
+                </a:solidFill>
+                <a:latin typeface="+mn-lt"/>
+                <a:ea typeface="+mn-ea"/>
+                <a:cs typeface="+mn-cs"/>
+              </a:defRPr>
+            </a:lvl9pPr>
+          </a:lstStyle>
+          <a:p>
+            <a:pPr>
+              <a:spcBef>
+                <a:spcPct val="0"/>
+              </a:spcBef>
+              <a:spcAft>
+                <a:spcPct val="0"/>
+              </a:spcAft>
+            </a:pPr>
+            <a:r>
+              <a:rPr lang="en-US" sz="1400" b="1" dirty="0">
+                <a:solidFill>
+                  <a:srgbClr val="000000"/>
+                </a:solidFill>
+                <a:latin typeface="Arial"/>
+              </a:rPr>
+              <a:t>Delivered in collaboration with the St George’s Hospital Imaging Research Group </a:t>
+            </a:r>
+            <a:endParaRPr lang="en-US" sz="1400" dirty="0">
+              <a:latin typeface="Arial"/>
+            </a:endParaRPr>
+          </a:p>
+        </p:txBody>
+      </p:sp>
     </p:spTree>
     <p:extLst>
       <p:ext uri="{BB962C8B-B14F-4D97-AF65-F5344CB8AC3E}">
@@ -13513,50 +14607,32 @@
               </a:spcAft>
             </a:pPr>
             <a:r>
-              <a:rPr lang="en-US" sz="2800" b="1" dirty="0">
+              <a:rPr lang="en-US" sz="2800" b="1">
                 <a:solidFill>
                   <a:srgbClr val="000000"/>
                 </a:solidFill>
                 <a:latin typeface="Arial"/>
               </a:rPr>
-              <a:t>Research </a:t>
-            </a:r>
-            <a:r>
+              <a:t>Research Projects at St George's</a:t>
+            </a:r>
+            <a:br>
               <a:rPr lang="en-US" sz="2800" b="1">
                 <a:solidFill>
                   <a:srgbClr val="000000"/>
                 </a:solidFill>
                 <a:latin typeface="Arial"/>
               </a:rPr>
-              <a:t>Projects</a:t>
-            </a:r>
-            <a:r>
-              <a:rPr lang="en-US" sz="2800" b="1" dirty="0">
+            </a:br>
+            <a:r>
+              <a:rPr lang="en-US" sz="2800" b="1">
                 <a:solidFill>
                   <a:srgbClr val="000000"/>
                 </a:solidFill>
                 <a:latin typeface="Arial"/>
               </a:rPr>
-              <a:t> at St George's</a:t>
-            </a:r>
-            <a:br>
-              <a:rPr lang="en-US" sz="2800" b="1" dirty="0">
-                <a:solidFill>
-                  <a:srgbClr val="000000"/>
-                </a:solidFill>
-                <a:latin typeface="Arial"/>
-              </a:rPr>
-            </a:br>
-            <a:r>
-              <a:rPr lang="en-US" sz="2800" b="1" dirty="0">
-                <a:solidFill>
-                  <a:srgbClr val="000000"/>
-                </a:solidFill>
-                <a:latin typeface="Arial"/>
-              </a:rPr>
               <a:t>NHS Foundation Trust</a:t>
             </a:r>
-            <a:endParaRPr lang="en-US" dirty="0"/>
+            <a:endParaRPr lang="en-US"/>
           </a:p>
         </p:txBody>
       </p:sp>
@@ -13628,7 +14704,7 @@
             <a:pPr marL="0" indent="0" algn="ctr">
               <a:buNone/>
             </a:pPr>
-            <a:endParaRPr lang="en-US" sz="1800" b="1" dirty="0">
+            <a:endParaRPr lang="en-US" sz="1800" b="1">
               <a:solidFill>
                 <a:srgbClr val="B5A9A1"/>
               </a:solidFill>
@@ -13701,7 +14777,7 @@
                 <a:spcPct val="0"/>
               </a:spcAft>
             </a:pPr>
-            <a:endParaRPr lang="en-US" dirty="0">
+            <a:endParaRPr lang="en-US">
               <a:solidFill>
                 <a:srgbClr val="000000"/>
               </a:solidFill>
@@ -13748,7 +14824,7 @@
                 <a:spcPct val="0"/>
               </a:spcAft>
             </a:pPr>
-            <a:endParaRPr lang="en-US" b="1" dirty="0">
+            <a:endParaRPr lang="en-US" b="1">
               <a:solidFill>
                 <a:srgbClr val="000000"/>
               </a:solidFill>
@@ -13880,6 +14956,94 @@
           </a:prstGeom>
         </p:spPr>
       </p:pic>
+      <p:grpSp>
+        <p:nvGrpSpPr>
+          <p:cNvPr id="13" name="Group 12">
+            <a:extLst>
+              <a:ext uri="{FF2B5EF4-FFF2-40B4-BE49-F238E27FC236}">
+                <a16:creationId xmlns:a16="http://schemas.microsoft.com/office/drawing/2014/main" id="{5C3219E7-515A-8937-3FEC-3804BBA22871}"/>
+              </a:ext>
+            </a:extLst>
+          </p:cNvPr>
+          <p:cNvGrpSpPr/>
+          <p:nvPr/>
+        </p:nvGrpSpPr>
+        <p:grpSpPr>
+          <a:xfrm>
+            <a:off x="9141720" y="5995705"/>
+            <a:ext cx="2989243" cy="783793"/>
+            <a:chOff x="9141720" y="5995705"/>
+            <a:chExt cx="2989243" cy="783793"/>
+          </a:xfrm>
+        </p:grpSpPr>
+        <p:pic>
+          <p:nvPicPr>
+            <p:cNvPr id="14" name="Picture 13">
+              <a:extLst>
+                <a:ext uri="{FF2B5EF4-FFF2-40B4-BE49-F238E27FC236}">
+                  <a16:creationId xmlns:a16="http://schemas.microsoft.com/office/drawing/2014/main" id="{2E53EC23-49A6-5A93-01B3-B537C98E5670}"/>
+                </a:ext>
+              </a:extLst>
+            </p:cNvPr>
+            <p:cNvPicPr>
+              <a:picLocks noChangeAspect="1"/>
+            </p:cNvPicPr>
+            <p:nvPr/>
+          </p:nvPicPr>
+          <p:blipFill>
+            <a:blip r:embed="rId5"/>
+            <a:srcRect b="17602"/>
+            <a:stretch/>
+          </p:blipFill>
+          <p:spPr>
+            <a:xfrm>
+              <a:off x="9141720" y="5995705"/>
+              <a:ext cx="2212144" cy="783793"/>
+            </a:xfrm>
+            <a:prstGeom prst="rect">
+              <a:avLst/>
+            </a:prstGeom>
+          </p:spPr>
+        </p:pic>
+        <p:pic>
+          <p:nvPicPr>
+            <p:cNvPr id="15" name="Picture 14">
+              <a:extLst>
+                <a:ext uri="{FF2B5EF4-FFF2-40B4-BE49-F238E27FC236}">
+                  <a16:creationId xmlns:a16="http://schemas.microsoft.com/office/drawing/2014/main" id="{A2A14422-330D-6022-63B1-09A3F341C782}"/>
+                </a:ext>
+              </a:extLst>
+            </p:cNvPr>
+            <p:cNvPicPr>
+              <a:picLocks noChangeAspect="1"/>
+            </p:cNvPicPr>
+            <p:nvPr/>
+          </p:nvPicPr>
+          <p:blipFill>
+            <a:blip r:embed="rId6" cstate="print">
+              <a:extLst>
+                <a:ext uri="{28A0092B-C50C-407E-A947-70E740481C1C}">
+                  <a14:useLocalDpi xmlns:a14="http://schemas.microsoft.com/office/drawing/2010/main" val="0"/>
+                </a:ext>
+              </a:extLst>
+            </a:blip>
+            <a:srcRect t="-629" b="370"/>
+            <a:stretch/>
+          </p:blipFill>
+          <p:spPr>
+            <a:xfrm>
+              <a:off x="11336367" y="5995705"/>
+              <a:ext cx="794596" cy="783793"/>
+            </a:xfrm>
+            <a:prstGeom prst="rect">
+              <a:avLst/>
+            </a:prstGeom>
+            <a:solidFill>
+              <a:schemeClr val="bg1"/>
+            </a:solidFill>
+          </p:spPr>
+        </p:pic>
+      </p:grpSp>
     </p:spTree>
     <p:extLst>
       <p:ext uri="{BB962C8B-B14F-4D97-AF65-F5344CB8AC3E}">

</xml_diff>